<commit_message>
Bring the 1021 report in line with the 20 Oct meeting: SE01/CU01 on the end face, the pump reopened, and a piping-principles page.
Co-authored-by: peterli0913 <peterli0913@users.noreply.github.com>
</commit_message>
<xml_diff>
--- a/Progress_Report_1021.pptx
+++ b/Progress_Report_1021.pptx
@@ -12,6 +12,7 @@
     <p:sldId id="260" r:id="rId11"/>
     <p:sldId id="261" r:id="rId12"/>
     <p:sldId id="262" r:id="rId13"/>
+    <p:sldId id="263" r:id="rId14"/>
   </p:sldIdLst>
   <p:sldSz cx="12191695" cy="6858000" type="screen4x3"/>
   <p:notesSz cx="6858000" cy="9144000"/>
@@ -3938,7 +3939,7 @@
                 </a:solidFill>
                 <a:latin typeface="Segoe UI"/>
               </a:rPr>
-              <a:t>Progress 2026-09-23 ~ 10-21    ·    01 / 07</a:t>
+              <a:t>Progress 2026-09-23 ~ 10-21    ·    01 / 08</a:t>
             </a:r>
           </a:p>
         </p:txBody>
@@ -4113,7 +4114,7 @@
                 </a:solidFill>
                 <a:latin typeface="Segoe UI"/>
               </a:rPr>
-              <a:t>Layout — Settled and Open Points</a:t>
+              <a:t>Layout — Settled Points</a:t>
             </a:r>
           </a:p>
           <a:p>
@@ -4705,7 +4706,7 @@
             <a:avLst/>
           </a:prstGeom>
           <a:solidFill>
-            <a:srgbClr val="D97706"/>
+            <a:srgbClr val="16A34A"/>
           </a:solidFill>
           <a:ln>
             <a:noFill/>
@@ -4761,7 +4762,7 @@
                 </a:solidFill>
                 <a:latin typeface="Segoe UI"/>
               </a:rPr>
-              <a:t>Open: SE01 / CU01 — wall side or end face of module 3.  Drain and CIP valves at the front.</a:t>
+              <a:t>SE01 / CU01 go on the end face of module 3, reachable from the end (SW choice, 20 Oct).</a:t>
             </a:r>
           </a:p>
           <a:p>
@@ -4786,7 +4787,7 @@
                 </a:solidFill>
                 <a:latin typeface="Segoe UI"/>
               </a:rPr>
-              <a:t>The end-face option clashes with the Reactor 3 HTF.  Both points are in the 20 Oct model for SW review.</a:t>
+              <a:t>Separator level switches move to that side.  The Reactor 3 HTF clash in this option is being resolved.</a:t>
             </a:r>
           </a:p>
           <a:p>
@@ -4811,7 +4812,7 @@
                 </a:solidFill>
                 <a:latin typeface="Segoe UI"/>
               </a:rPr>
-              <a:t>Valves within 300–400 mm of the end stay manual; beyond that, compact actuated valves.</a:t>
+              <a:t>The separator top keeps its Class 900 flange: a welded dished head cannot take all the nozzles.</a:t>
             </a:r>
           </a:p>
         </p:txBody>
@@ -4880,7 +4881,7 @@
                 </a:solidFill>
                 <a:latin typeface="Segoe UI"/>
               </a:rPr>
-              <a:t>Progress 2026-09-23 ~ 10-21    ·    02 / 07</a:t>
+              <a:t>Progress 2026-09-23 ~ 10-21    ·    02 / 08</a:t>
             </a:r>
           </a:p>
         </p:txBody>
@@ -5129,7 +5130,7 @@
         <p:spPr>
           <a:xfrm>
             <a:off x="502920" y="1481328"/>
-            <a:ext cx="11183112" cy="1997075"/>
+            <a:ext cx="11183112" cy="1735836"/>
           </a:xfrm>
           <a:prstGeom prst="roundRect">
             <a:avLst/>
@@ -5175,13 +5176,13 @@
         <p:spPr>
           <a:xfrm>
             <a:off x="502920" y="1481328"/>
-            <a:ext cx="64008" cy="1997075"/>
+            <a:ext cx="64008" cy="1735836"/>
           </a:xfrm>
           <a:prstGeom prst="rect">
             <a:avLst/>
           </a:prstGeom>
           <a:solidFill>
-            <a:srgbClr val="16A34A"/>
+            <a:srgbClr val="B45309"/>
           </a:solidFill>
           <a:ln>
             <a:noFill/>
@@ -5219,7 +5220,7 @@
         <p:spPr>
           <a:xfrm>
             <a:off x="749808" y="1545336"/>
-            <a:ext cx="10744200" cy="1905635"/>
+            <a:ext cx="10744200" cy="1644396"/>
           </a:xfrm>
           <a:prstGeom prst="rect">
             <a:avLst/>
@@ -5237,7 +5238,7 @@
                 </a:solidFill>
                 <a:latin typeface="Segoe UI"/>
               </a:rPr>
-              <a:t>Metering pump: a three-head pump with inlet and outlet manifolds and no discharge damper replaces the single head with a pulsation damper.</a:t>
+              <a:t>Metering pump — open.  SW wants the pulsation damper removed; the vendor's alternative is a three-head pump with manifolds and no damper.</a:t>
             </a:r>
           </a:p>
           <a:p>
@@ -5262,7 +5263,7 @@
                 </a:solidFill>
                 <a:latin typeface="Segoe UI"/>
               </a:rPr>
-              <a:t>Addresses SW's concern: the damper is a dead leg, and a diaphragm failure could go undetected.</a:t>
+              <a:t>SW is not keen on the three-head option (20 Oct).  The vendor does not recommend a single head without a damper at this pressure.</a:t>
             </a:r>
           </a:p>
           <a:p>
@@ -5287,7 +5288,7 @@
                 </a:solidFill>
                 <a:latin typeface="Segoe UI"/>
               </a:rPr>
-              <a:t>Vendor drawing received 20 Oct and placed in the 3D; pulsation curves supplied.  20 L/h, 7.5 MPa discharge, GMP.</a:t>
+              <a:t>CFCT will send SW the vendor discussion and the pulsation curves for both options.  Three-head basis: 20 L/h, 7.5 MPa, GMP.</a:t>
             </a:r>
           </a:p>
           <a:p>
@@ -5315,31 +5316,6 @@
               <a:t>CE marking is sufficient; no foreign motor brand is required (15 Oct).</a:t>
             </a:r>
           </a:p>
-          <a:p>
-            <a:pPr>
-              <a:spcBef>
-                <a:spcPts val="400"/>
-              </a:spcBef>
-            </a:pPr>
-            <a:r>
-              <a:rPr sz="1300" b="0" i="0">
-                <a:solidFill>
-                  <a:srgbClr val="94A3B8"/>
-                </a:solidFill>
-                <a:latin typeface="Segoe UI"/>
-              </a:rPr>
-              <a:t>–  </a:t>
-            </a:r>
-            <a:r>
-              <a:rPr sz="1300" b="0" i="0">
-                <a:solidFill>
-                  <a:srgbClr val="5B6B80"/>
-                </a:solidFill>
-                <a:latin typeface="Segoe UI"/>
-              </a:rPr>
-              <a:t>Vendor: flow can be calibrated on site for each material; a flowmeter is needed only for remote flow indication.  To be confirmed by process.</a:t>
-            </a:r>
-          </a:p>
         </p:txBody>
       </p:sp>
       <p:sp>
@@ -5350,8 +5326,8 @@
         </p:nvSpPr>
         <p:spPr>
           <a:xfrm>
-            <a:off x="502920" y="3588131"/>
-            <a:ext cx="11183112" cy="1474596"/>
+            <a:off x="502920" y="3326892"/>
+            <a:ext cx="11183112" cy="1426972"/>
           </a:xfrm>
           <a:prstGeom prst="roundRect">
             <a:avLst/>
@@ -5396,8 +5372,8 @@
         </p:nvSpPr>
         <p:spPr>
           <a:xfrm>
-            <a:off x="502920" y="3588131"/>
-            <a:ext cx="64008" cy="1474596"/>
+            <a:off x="502920" y="3326892"/>
+            <a:ext cx="64008" cy="1426972"/>
           </a:xfrm>
           <a:prstGeom prst="rect">
             <a:avLst/>
@@ -5440,8 +5416,8 @@
         </p:nvSpPr>
         <p:spPr>
           <a:xfrm>
-            <a:off x="749808" y="3652139"/>
-            <a:ext cx="10744200" cy="1383156"/>
+            <a:off x="749808" y="3390900"/>
+            <a:ext cx="10744200" cy="1335532"/>
           </a:xfrm>
           <a:prstGeom prst="rect">
             <a:avLst/>
@@ -5459,7 +5435,7 @@
                 </a:solidFill>
                 <a:latin typeface="Segoe UI"/>
               </a:rPr>
-              <a:t>Reactor temperatures: SW's multipoint RTD concept is feasible — no local transmitters or displays; readings on the HMI.</a:t>
+              <a:t>Reactor temperatures: no local transmitters or displays; readings on the HMI.</a:t>
             </a:r>
           </a:p>
           <a:p>
@@ -5484,7 +5460,7 @@
                 </a:solidFill>
                 <a:latin typeface="Segoe UI"/>
               </a:rPr>
-              <a:t>E+H iTherm MultiSens Slim TMS21 on flexible conduit, wired direct to Siemens RTD module 6ES7134-7SD51-0AB0 in the ET200iSP panel.</a:t>
+              <a:t>Multipoint: E+H iTherm MultiSens Slim TMS21 on flexible conduit, wired direct to Siemens RTD module 6ES7134-7SD51-0AB0.  E+H and Siemens have confirmed supply.</a:t>
             </a:r>
           </a:p>
           <a:p>
@@ -5509,7 +5485,7 @@
                 </a:solidFill>
                 <a:latin typeface="Segoe UI"/>
               </a:rPr>
-              <a:t>E+H has confirmed supply; Siemens has confirmed the RTD module.  Parameter review with E+H this week.</a:t>
+              <a:t>Single points: small transmitters without display, or RTDs wired direct to the IS I/O panel as SW proposes — to be agreed.  Flexible conduit is acceptable inside the skid (IS circuits).</a:t>
             </a:r>
           </a:p>
         </p:txBody>
@@ -5522,7 +5498,7 @@
         </p:nvSpPr>
         <p:spPr>
           <a:xfrm>
-            <a:off x="502920" y="5172456"/>
+            <a:off x="502920" y="4863592"/>
             <a:ext cx="11183112" cy="745744"/>
           </a:xfrm>
           <a:prstGeom prst="roundRect">
@@ -5568,7 +5544,7 @@
         </p:nvSpPr>
         <p:spPr>
           <a:xfrm>
-            <a:off x="502920" y="5172456"/>
+            <a:off x="502920" y="4863592"/>
             <a:ext cx="64008" cy="745744"/>
           </a:xfrm>
           <a:prstGeom prst="rect">
@@ -5612,7 +5588,7 @@
         </p:nvSpPr>
         <p:spPr>
           <a:xfrm>
-            <a:off x="749808" y="5236464"/>
+            <a:off x="749808" y="4927600"/>
             <a:ext cx="10744200" cy="654304"/>
           </a:xfrm>
           <a:prstGeom prst="rect">
@@ -5700,7 +5676,7 @@
                 </a:solidFill>
                 <a:latin typeface="Segoe UI"/>
               </a:rPr>
-              <a:t>Progress 2026-09-23 ~ 10-21    ·    03 / 07</a:t>
+              <a:t>Progress 2026-09-23 ~ 10-21    ·    03 / 08</a:t>
             </a:r>
           </a:p>
         </p:txBody>
@@ -5738,7 +5714,7 @@
             <a:avLst/>
           </a:prstGeom>
           <a:solidFill>
-            <a:srgbClr val="DC2626"/>
+            <a:srgbClr val="16A34A"/>
           </a:solidFill>
           <a:ln>
             <a:noFill/>
@@ -5779,6 +5755,879 @@
             <a:ext cx="841248" cy="841248"/>
           </a:xfrm>
           <a:prstGeom prst="roundRect">
+            <a:avLst/>
+          </a:prstGeom>
+          <a:solidFill>
+            <a:srgbClr val="16A34A"/>
+          </a:solidFill>
+          <a:ln>
+            <a:noFill/>
+          </a:ln>
+          <a:effectLst/>
+        </p:spPr>
+        <p:style>
+          <a:lnRef idx="1">
+            <a:schemeClr val="accent1"/>
+          </a:lnRef>
+          <a:fillRef idx="3">
+            <a:schemeClr val="accent1"/>
+          </a:fillRef>
+          <a:effectRef idx="2">
+            <a:schemeClr val="accent1"/>
+          </a:effectRef>
+          <a:fontRef idx="minor">
+            <a:schemeClr val="lt1"/>
+          </a:fontRef>
+        </p:style>
+        <p:txBody>
+          <a:bodyPr rtlCol="0" anchor="ctr"/>
+          <a:lstStyle/>
+          <a:p>
+            <a:pPr algn="ctr"/>
+          </a:p>
+        </p:txBody>
+      </p:sp>
+      <p:sp>
+        <p:nvSpPr>
+          <p:cNvPr id="4" name="TextBox 3"/>
+          <p:cNvSpPr txBox="1"/>
+          <p:nvPr/>
+        </p:nvSpPr>
+        <p:spPr>
+          <a:xfrm>
+            <a:off x="502920" y="347472"/>
+            <a:ext cx="841248" cy="841248"/>
+          </a:xfrm>
+          <a:prstGeom prst="rect">
+            <a:avLst/>
+          </a:prstGeom>
+          <a:noFill/>
+        </p:spPr>
+        <p:txBody>
+          <a:bodyPr wrap="none" anchor="ctr" lIns="0" rIns="0" tIns="0" bIns="0">
+            <a:spAutoFit/>
+          </a:bodyPr>
+          <a:lstStyle/>
+          <a:p>
+            <a:pPr algn="ctr"/>
+            <a:r>
+              <a:rPr sz="3200" b="1" i="0">
+                <a:solidFill>
+                  <a:srgbClr val="FFFFFF"/>
+                </a:solidFill>
+                <a:latin typeface="Segoe UI"/>
+              </a:rPr>
+              <a:t>04</a:t>
+            </a:r>
+          </a:p>
+        </p:txBody>
+      </p:sp>
+      <p:sp>
+        <p:nvSpPr>
+          <p:cNvPr id="5" name="TextBox 4"/>
+          <p:cNvSpPr txBox="1"/>
+          <p:nvPr/>
+        </p:nvSpPr>
+        <p:spPr>
+          <a:xfrm>
+            <a:off x="1536192" y="365760"/>
+            <a:ext cx="10058400" cy="804672"/>
+          </a:xfrm>
+          <a:prstGeom prst="rect">
+            <a:avLst/>
+          </a:prstGeom>
+          <a:noFill/>
+        </p:spPr>
+        <p:txBody>
+          <a:bodyPr wrap="square" lIns="0" rIns="0" anchor="ctr">
+            <a:spAutoFit/>
+          </a:bodyPr>
+          <a:lstStyle/>
+          <a:p>
+            <a:r>
+              <a:rPr sz="2800" b="1" i="0">
+                <a:solidFill>
+                  <a:srgbClr val="16A34A"/>
+                </a:solidFill>
+                <a:latin typeface="Segoe UI"/>
+              </a:rPr>
+              <a:t>Detailed Review — Piping and Valves</a:t>
+            </a:r>
+          </a:p>
+          <a:p>
+            <a:pPr>
+              <a:spcBef>
+                <a:spcPts val="100"/>
+              </a:spcBef>
+            </a:pPr>
+            <a:r>
+              <a:rPr sz="1400" b="0" i="0">
+                <a:solidFill>
+                  <a:srgbClr val="8A97AB"/>
+                </a:solidFill>
+                <a:latin typeface="Segoe UI"/>
+              </a:rPr>
+              <a:t>Principles agreed with SW on 20 October</a:t>
+            </a:r>
+          </a:p>
+        </p:txBody>
+      </p:sp>
+      <p:sp>
+        <p:nvSpPr>
+          <p:cNvPr id="6" name="Rectangle 5"/>
+          <p:cNvSpPr/>
+          <p:nvPr/>
+        </p:nvSpPr>
+        <p:spPr>
+          <a:xfrm>
+            <a:off x="502920" y="1335024"/>
+            <a:ext cx="11183112" cy="13716"/>
+          </a:xfrm>
+          <a:prstGeom prst="rect">
+            <a:avLst/>
+          </a:prstGeom>
+          <a:solidFill>
+            <a:srgbClr val="E3E8F0"/>
+          </a:solidFill>
+          <a:ln>
+            <a:noFill/>
+          </a:ln>
+          <a:effectLst/>
+        </p:spPr>
+        <p:style>
+          <a:lnRef idx="1">
+            <a:schemeClr val="accent1"/>
+          </a:lnRef>
+          <a:fillRef idx="3">
+            <a:schemeClr val="accent1"/>
+          </a:fillRef>
+          <a:effectRef idx="2">
+            <a:schemeClr val="accent1"/>
+          </a:effectRef>
+          <a:fontRef idx="minor">
+            <a:schemeClr val="lt1"/>
+          </a:fontRef>
+        </p:style>
+        <p:txBody>
+          <a:bodyPr rtlCol="0" anchor="ctr"/>
+          <a:lstStyle/>
+          <a:p>
+            <a:pPr algn="ctr"/>
+          </a:p>
+        </p:txBody>
+      </p:sp>
+      <p:sp>
+        <p:nvSpPr>
+          <p:cNvPr id="7" name="Rounded Rectangle 6"/>
+          <p:cNvSpPr/>
+          <p:nvPr/>
+        </p:nvSpPr>
+        <p:spPr>
+          <a:xfrm>
+            <a:off x="502920" y="1481328"/>
+            <a:ext cx="11183112" cy="959358"/>
+          </a:xfrm>
+          <a:prstGeom prst="roundRect">
+            <a:avLst/>
+          </a:prstGeom>
+          <a:solidFill>
+            <a:srgbClr val="F4F7FB"/>
+          </a:solidFill>
+          <a:ln w="12700">
+            <a:solidFill>
+              <a:srgbClr val="E3E8F0"/>
+            </a:solidFill>
+          </a:ln>
+          <a:effectLst/>
+        </p:spPr>
+        <p:style>
+          <a:lnRef idx="1">
+            <a:schemeClr val="accent1"/>
+          </a:lnRef>
+          <a:fillRef idx="3">
+            <a:schemeClr val="accent1"/>
+          </a:fillRef>
+          <a:effectRef idx="2">
+            <a:schemeClr val="accent1"/>
+          </a:effectRef>
+          <a:fontRef idx="minor">
+            <a:schemeClr val="lt1"/>
+          </a:fontRef>
+        </p:style>
+        <p:txBody>
+          <a:bodyPr rtlCol="0" anchor="ctr"/>
+          <a:lstStyle/>
+          <a:p>
+            <a:pPr algn="ctr"/>
+          </a:p>
+        </p:txBody>
+      </p:sp>
+      <p:sp>
+        <p:nvSpPr>
+          <p:cNvPr id="8" name="Rectangle 7"/>
+          <p:cNvSpPr/>
+          <p:nvPr/>
+        </p:nvSpPr>
+        <p:spPr>
+          <a:xfrm>
+            <a:off x="502920" y="1481328"/>
+            <a:ext cx="64008" cy="959358"/>
+          </a:xfrm>
+          <a:prstGeom prst="rect">
+            <a:avLst/>
+          </a:prstGeom>
+          <a:solidFill>
+            <a:srgbClr val="16A34A"/>
+          </a:solidFill>
+          <a:ln>
+            <a:noFill/>
+          </a:ln>
+          <a:effectLst/>
+        </p:spPr>
+        <p:style>
+          <a:lnRef idx="1">
+            <a:schemeClr val="accent1"/>
+          </a:lnRef>
+          <a:fillRef idx="3">
+            <a:schemeClr val="accent1"/>
+          </a:fillRef>
+          <a:effectRef idx="2">
+            <a:schemeClr val="accent1"/>
+          </a:effectRef>
+          <a:fontRef idx="minor">
+            <a:schemeClr val="lt1"/>
+          </a:fontRef>
+        </p:style>
+        <p:txBody>
+          <a:bodyPr rtlCol="0" anchor="ctr"/>
+          <a:lstStyle/>
+          <a:p>
+            <a:pPr algn="ctr"/>
+          </a:p>
+        </p:txBody>
+      </p:sp>
+      <p:sp>
+        <p:nvSpPr>
+          <p:cNvPr id="9" name="TextBox 8"/>
+          <p:cNvSpPr txBox="1"/>
+          <p:nvPr/>
+        </p:nvSpPr>
+        <p:spPr>
+          <a:xfrm>
+            <a:off x="749808" y="1545336"/>
+            <a:ext cx="10744200" cy="867918"/>
+          </a:xfrm>
+          <a:prstGeom prst="rect">
+            <a:avLst/>
+          </a:prstGeom>
+          <a:noFill/>
+        </p:spPr>
+        <p:txBody>
+          <a:bodyPr wrap="square" lIns="0" rIns="0" tIns="0" bIns="0"/>
+          <a:lstStyle/>
+          <a:p>
+            <a:r>
+              <a:rPr sz="1600" b="1" i="0">
+                <a:solidFill>
+                  <a:srgbClr val="1E2B3A"/>
+                </a:solidFill>
+                <a:latin typeface="Segoe UI"/>
+              </a:rPr>
+              <a:t>Equipment positions are held.  Each P&amp;ID line is now walked through on the model, start to finish.</a:t>
+            </a:r>
+          </a:p>
+          <a:p>
+            <a:pPr>
+              <a:spcBef>
+                <a:spcPts val="400"/>
+              </a:spcBef>
+            </a:pPr>
+            <a:r>
+              <a:rPr sz="1300" b="0" i="0">
+                <a:solidFill>
+                  <a:srgbClr val="94A3B8"/>
+                </a:solidFill>
+                <a:latin typeface="Segoe UI"/>
+              </a:rPr>
+              <a:t>–  </a:t>
+            </a:r>
+            <a:r>
+              <a:rPr sz="1300" b="0" i="0">
+                <a:solidFill>
+                  <a:srgbClr val="5B6B80"/>
+                </a:solidFill>
+                <a:latin typeface="Segoe UI"/>
+              </a:rPr>
+              <a:t>Check vents, drains, dead legs, low points and pockets, and match to the P&amp;ID.  Fix on the spot or log a comment; update the P&amp;ID with every change.</a:t>
+            </a:r>
+          </a:p>
+        </p:txBody>
+      </p:sp>
+      <p:sp>
+        <p:nvSpPr>
+          <p:cNvPr id="10" name="Rounded Rectangle 9"/>
+          <p:cNvSpPr/>
+          <p:nvPr/>
+        </p:nvSpPr>
+        <p:spPr>
+          <a:xfrm>
+            <a:off x="502920" y="2532126"/>
+            <a:ext cx="11183112" cy="1014222"/>
+          </a:xfrm>
+          <a:prstGeom prst="roundRect">
+            <a:avLst/>
+          </a:prstGeom>
+          <a:solidFill>
+            <a:srgbClr val="F4F7FB"/>
+          </a:solidFill>
+          <a:ln w="12700">
+            <a:solidFill>
+              <a:srgbClr val="E3E8F0"/>
+            </a:solidFill>
+          </a:ln>
+          <a:effectLst/>
+        </p:spPr>
+        <p:style>
+          <a:lnRef idx="1">
+            <a:schemeClr val="accent1"/>
+          </a:lnRef>
+          <a:fillRef idx="3">
+            <a:schemeClr val="accent1"/>
+          </a:fillRef>
+          <a:effectRef idx="2">
+            <a:schemeClr val="accent1"/>
+          </a:effectRef>
+          <a:fontRef idx="minor">
+            <a:schemeClr val="lt1"/>
+          </a:fontRef>
+        </p:style>
+        <p:txBody>
+          <a:bodyPr rtlCol="0" anchor="ctr"/>
+          <a:lstStyle/>
+          <a:p>
+            <a:pPr algn="ctr"/>
+          </a:p>
+        </p:txBody>
+      </p:sp>
+      <p:sp>
+        <p:nvSpPr>
+          <p:cNvPr id="11" name="Rectangle 10"/>
+          <p:cNvSpPr/>
+          <p:nvPr/>
+        </p:nvSpPr>
+        <p:spPr>
+          <a:xfrm>
+            <a:off x="502920" y="2532126"/>
+            <a:ext cx="64008" cy="1014222"/>
+          </a:xfrm>
+          <a:prstGeom prst="rect">
+            <a:avLst/>
+          </a:prstGeom>
+          <a:solidFill>
+            <a:srgbClr val="16A34A"/>
+          </a:solidFill>
+          <a:ln>
+            <a:noFill/>
+          </a:ln>
+          <a:effectLst/>
+        </p:spPr>
+        <p:style>
+          <a:lnRef idx="1">
+            <a:schemeClr val="accent1"/>
+          </a:lnRef>
+          <a:fillRef idx="3">
+            <a:schemeClr val="accent1"/>
+          </a:fillRef>
+          <a:effectRef idx="2">
+            <a:schemeClr val="accent1"/>
+          </a:effectRef>
+          <a:fontRef idx="minor">
+            <a:schemeClr val="lt1"/>
+          </a:fontRef>
+        </p:style>
+        <p:txBody>
+          <a:bodyPr rtlCol="0" anchor="ctr"/>
+          <a:lstStyle/>
+          <a:p>
+            <a:pPr algn="ctr"/>
+          </a:p>
+        </p:txBody>
+      </p:sp>
+      <p:sp>
+        <p:nvSpPr>
+          <p:cNvPr id="12" name="TextBox 11"/>
+          <p:cNvSpPr txBox="1"/>
+          <p:nvPr/>
+        </p:nvSpPr>
+        <p:spPr>
+          <a:xfrm>
+            <a:off x="749808" y="2596134"/>
+            <a:ext cx="10744200" cy="922782"/>
+          </a:xfrm>
+          <a:prstGeom prst="rect">
+            <a:avLst/>
+          </a:prstGeom>
+          <a:noFill/>
+        </p:spPr>
+        <p:txBody>
+          <a:bodyPr wrap="square" lIns="0" rIns="0" tIns="0" bIns="0"/>
+          <a:lstStyle/>
+          <a:p>
+            <a:r>
+              <a:rPr sz="1600" b="1" i="0">
+                <a:solidFill>
+                  <a:srgbClr val="1E2B3A"/>
+                </a:solidFill>
+                <a:latin typeface="Segoe UI"/>
+              </a:rPr>
+              <a:t>Remove what is not needed.  CV06 goes; its feed interlock moves to CV12.</a:t>
+            </a:r>
+          </a:p>
+          <a:p>
+            <a:pPr>
+              <a:spcBef>
+                <a:spcPts val="400"/>
+              </a:spcBef>
+            </a:pPr>
+            <a:r>
+              <a:rPr sz="1300" b="0" i="0">
+                <a:solidFill>
+                  <a:srgbClr val="94A3B8"/>
+                </a:solidFill>
+                <a:latin typeface="Segoe UI"/>
+              </a:rPr>
+              <a:t>–  </a:t>
+            </a:r>
+            <a:r>
+              <a:rPr sz="1300" b="0" i="0">
+                <a:solidFill>
+                  <a:srgbClr val="5B6B80"/>
+                </a:solidFill>
+                <a:latin typeface="Segoe UI"/>
+              </a:rPr>
+              <a:t>Next candidates: the drain beside FIT01, one of two adjacent isolation valves, and a tee moved down to shorten a dead leg.</a:t>
+            </a:r>
+          </a:p>
+          <a:p>
+            <a:pPr>
+              <a:spcBef>
+                <a:spcPts val="400"/>
+              </a:spcBef>
+            </a:pPr>
+            <a:r>
+              <a:rPr sz="1300" b="0" i="0">
+                <a:solidFill>
+                  <a:srgbClr val="94A3B8"/>
+                </a:solidFill>
+                <a:latin typeface="Segoe UI"/>
+              </a:rPr>
+              <a:t>–  </a:t>
+            </a:r>
+            <a:r>
+              <a:rPr sz="1300" b="0" i="0">
+                <a:solidFill>
+                  <a:srgbClr val="5B6B80"/>
+                </a:solidFill>
+                <a:latin typeface="Segoe UI"/>
+              </a:rPr>
+              <a:t>One drain may serve where the final rinse is emptied; individual legs rarely need draining on their own.</a:t>
+            </a:r>
+          </a:p>
+        </p:txBody>
+      </p:sp>
+      <p:sp>
+        <p:nvSpPr>
+          <p:cNvPr id="13" name="Rounded Rectangle 12"/>
+          <p:cNvSpPr/>
+          <p:nvPr/>
+        </p:nvSpPr>
+        <p:spPr>
+          <a:xfrm>
+            <a:off x="502920" y="3637788"/>
+            <a:ext cx="11183112" cy="1213358"/>
+          </a:xfrm>
+          <a:prstGeom prst="roundRect">
+            <a:avLst/>
+          </a:prstGeom>
+          <a:solidFill>
+            <a:srgbClr val="F4F7FB"/>
+          </a:solidFill>
+          <a:ln w="12700">
+            <a:solidFill>
+              <a:srgbClr val="E3E8F0"/>
+            </a:solidFill>
+          </a:ln>
+          <a:effectLst/>
+        </p:spPr>
+        <p:style>
+          <a:lnRef idx="1">
+            <a:schemeClr val="accent1"/>
+          </a:lnRef>
+          <a:fillRef idx="3">
+            <a:schemeClr val="accent1"/>
+          </a:fillRef>
+          <a:effectRef idx="2">
+            <a:schemeClr val="accent1"/>
+          </a:effectRef>
+          <a:fontRef idx="minor">
+            <a:schemeClr val="lt1"/>
+          </a:fontRef>
+        </p:style>
+        <p:txBody>
+          <a:bodyPr rtlCol="0" anchor="ctr"/>
+          <a:lstStyle/>
+          <a:p>
+            <a:pPr algn="ctr"/>
+          </a:p>
+        </p:txBody>
+      </p:sp>
+      <p:sp>
+        <p:nvSpPr>
+          <p:cNvPr id="14" name="Rectangle 13"/>
+          <p:cNvSpPr/>
+          <p:nvPr/>
+        </p:nvSpPr>
+        <p:spPr>
+          <a:xfrm>
+            <a:off x="502920" y="3637788"/>
+            <a:ext cx="64008" cy="1213358"/>
+          </a:xfrm>
+          <a:prstGeom prst="rect">
+            <a:avLst/>
+          </a:prstGeom>
+          <a:solidFill>
+            <a:srgbClr val="16A34A"/>
+          </a:solidFill>
+          <a:ln>
+            <a:noFill/>
+          </a:ln>
+          <a:effectLst/>
+        </p:spPr>
+        <p:style>
+          <a:lnRef idx="1">
+            <a:schemeClr val="accent1"/>
+          </a:lnRef>
+          <a:fillRef idx="3">
+            <a:schemeClr val="accent1"/>
+          </a:fillRef>
+          <a:effectRef idx="2">
+            <a:schemeClr val="accent1"/>
+          </a:effectRef>
+          <a:fontRef idx="minor">
+            <a:schemeClr val="lt1"/>
+          </a:fontRef>
+        </p:style>
+        <p:txBody>
+          <a:bodyPr rtlCol="0" anchor="ctr"/>
+          <a:lstStyle/>
+          <a:p>
+            <a:pPr algn="ctr"/>
+          </a:p>
+        </p:txBody>
+      </p:sp>
+      <p:sp>
+        <p:nvSpPr>
+          <p:cNvPr id="15" name="TextBox 14"/>
+          <p:cNvSpPr txBox="1"/>
+          <p:nvPr/>
+        </p:nvSpPr>
+        <p:spPr>
+          <a:xfrm>
+            <a:off x="749808" y="3701796"/>
+            <a:ext cx="10744200" cy="1121918"/>
+          </a:xfrm>
+          <a:prstGeom prst="rect">
+            <a:avLst/>
+          </a:prstGeom>
+          <a:noFill/>
+        </p:spPr>
+        <p:txBody>
+          <a:bodyPr wrap="square" lIns="0" rIns="0" tIns="0" bIns="0"/>
+          <a:lstStyle/>
+          <a:p>
+            <a:r>
+              <a:rPr sz="1600" b="1" i="0">
+                <a:solidFill>
+                  <a:srgbClr val="1E2B3A"/>
+                </a:solidFill>
+                <a:latin typeface="Segoe UI"/>
+              </a:rPr>
+              <a:t>Shortest routes, fewer fittings.  Hydrogen and feed lines follow the process order: preheater, then straight into Reactor 1 and across to Reactor 2.</a:t>
+            </a:r>
+          </a:p>
+          <a:p>
+            <a:pPr>
+              <a:spcBef>
+                <a:spcPts val="400"/>
+              </a:spcBef>
+            </a:pPr>
+            <a:r>
+              <a:rPr sz="1300" b="0" i="0">
+                <a:solidFill>
+                  <a:srgbClr val="94A3B8"/>
+                </a:solidFill>
+                <a:latin typeface="Segoe UI"/>
+              </a:rPr>
+              <a:t>–  </a:t>
+            </a:r>
+            <a:r>
+              <a:rPr sz="1300" b="0" i="0">
+                <a:solidFill>
+                  <a:srgbClr val="5B6B80"/>
+                </a:solidFill>
+                <a:latin typeface="Segoe UI"/>
+              </a:rPr>
+              <a:t>Drains leave from the side, not the bottom, so residue runs back into the main line.  Drain and spray-ball hose points are grouped at the front.</a:t>
+            </a:r>
+          </a:p>
+        </p:txBody>
+      </p:sp>
+      <p:sp>
+        <p:nvSpPr>
+          <p:cNvPr id="16" name="Rounded Rectangle 15"/>
+          <p:cNvSpPr/>
+          <p:nvPr/>
+        </p:nvSpPr>
+        <p:spPr>
+          <a:xfrm>
+            <a:off x="502920" y="4942586"/>
+            <a:ext cx="11183112" cy="1006982"/>
+          </a:xfrm>
+          <a:prstGeom prst="roundRect">
+            <a:avLst/>
+          </a:prstGeom>
+          <a:solidFill>
+            <a:srgbClr val="F4F7FB"/>
+          </a:solidFill>
+          <a:ln w="12700">
+            <a:solidFill>
+              <a:srgbClr val="E3E8F0"/>
+            </a:solidFill>
+          </a:ln>
+          <a:effectLst/>
+        </p:spPr>
+        <p:style>
+          <a:lnRef idx="1">
+            <a:schemeClr val="accent1"/>
+          </a:lnRef>
+          <a:fillRef idx="3">
+            <a:schemeClr val="accent1"/>
+          </a:fillRef>
+          <a:effectRef idx="2">
+            <a:schemeClr val="accent1"/>
+          </a:effectRef>
+          <a:fontRef idx="minor">
+            <a:schemeClr val="lt1"/>
+          </a:fontRef>
+        </p:style>
+        <p:txBody>
+          <a:bodyPr rtlCol="0" anchor="ctr"/>
+          <a:lstStyle/>
+          <a:p>
+            <a:pPr algn="ctr"/>
+          </a:p>
+        </p:txBody>
+      </p:sp>
+      <p:sp>
+        <p:nvSpPr>
+          <p:cNvPr id="17" name="Rectangle 16"/>
+          <p:cNvSpPr/>
+          <p:nvPr/>
+        </p:nvSpPr>
+        <p:spPr>
+          <a:xfrm>
+            <a:off x="502920" y="4942586"/>
+            <a:ext cx="64008" cy="1006982"/>
+          </a:xfrm>
+          <a:prstGeom prst="rect">
+            <a:avLst/>
+          </a:prstGeom>
+          <a:solidFill>
+            <a:srgbClr val="16A34A"/>
+          </a:solidFill>
+          <a:ln>
+            <a:noFill/>
+          </a:ln>
+          <a:effectLst/>
+        </p:spPr>
+        <p:style>
+          <a:lnRef idx="1">
+            <a:schemeClr val="accent1"/>
+          </a:lnRef>
+          <a:fillRef idx="3">
+            <a:schemeClr val="accent1"/>
+          </a:fillRef>
+          <a:effectRef idx="2">
+            <a:schemeClr val="accent1"/>
+          </a:effectRef>
+          <a:fontRef idx="minor">
+            <a:schemeClr val="lt1"/>
+          </a:fontRef>
+        </p:style>
+        <p:txBody>
+          <a:bodyPr rtlCol="0" anchor="ctr"/>
+          <a:lstStyle/>
+          <a:p>
+            <a:pPr algn="ctr"/>
+          </a:p>
+        </p:txBody>
+      </p:sp>
+      <p:sp>
+        <p:nvSpPr>
+          <p:cNvPr id="18" name="TextBox 17"/>
+          <p:cNvSpPr txBox="1"/>
+          <p:nvPr/>
+        </p:nvSpPr>
+        <p:spPr>
+          <a:xfrm>
+            <a:off x="749808" y="5006594"/>
+            <a:ext cx="10744200" cy="915542"/>
+          </a:xfrm>
+          <a:prstGeom prst="rect">
+            <a:avLst/>
+          </a:prstGeom>
+          <a:noFill/>
+        </p:spPr>
+        <p:txBody>
+          <a:bodyPr wrap="square" lIns="0" rIns="0" tIns="0" bIns="0"/>
+          <a:lstStyle/>
+          <a:p>
+            <a:r>
+              <a:rPr sz="1600" b="1" i="0">
+                <a:solidFill>
+                  <a:srgbClr val="1E2B3A"/>
+                </a:solidFill>
+                <a:latin typeface="Segoe UI"/>
+              </a:rPr>
+              <a:t>Jacket HTF nozzles to face the back wall.  Temperature element at the outlet elbow; flange faces back so the front module slides in onto it.</a:t>
+            </a:r>
+          </a:p>
+          <a:p>
+            <a:pPr>
+              <a:spcBef>
+                <a:spcPts val="400"/>
+              </a:spcBef>
+            </a:pPr>
+            <a:r>
+              <a:rPr sz="1300" b="0" i="0">
+                <a:solidFill>
+                  <a:srgbClr val="94A3B8"/>
+                </a:solidFill>
+                <a:latin typeface="Segoe UI"/>
+              </a:rPr>
+              <a:t>–  </a:t>
+            </a:r>
+            <a:r>
+              <a:rPr sz="1300" b="0" i="0">
+                <a:solidFill>
+                  <a:srgbClr val="5B6B80"/>
+                </a:solidFill>
+                <a:latin typeface="Segoe UI"/>
+              </a:rPr>
+              <a:t>CFCT will send a sketch of this arrangement to confirm it matches SW's intent.  The jacket keeps opposite-side inlet and outlet.</a:t>
+            </a:r>
+          </a:p>
+        </p:txBody>
+      </p:sp>
+      <p:sp>
+        <p:nvSpPr>
+          <p:cNvPr id="19" name="TextBox 18"/>
+          <p:cNvSpPr txBox="1"/>
+          <p:nvPr/>
+        </p:nvSpPr>
+        <p:spPr>
+          <a:xfrm>
+            <a:off x="548640" y="6446520"/>
+            <a:ext cx="6583680" cy="274320"/>
+          </a:xfrm>
+          <a:prstGeom prst="rect">
+            <a:avLst/>
+          </a:prstGeom>
+          <a:noFill/>
+        </p:spPr>
+        <p:txBody>
+          <a:bodyPr wrap="none">
+            <a:spAutoFit/>
+          </a:bodyPr>
+          <a:lstStyle/>
+          <a:p>
+            <a:r>
+              <a:rPr sz="900" b="0" i="0">
+                <a:solidFill>
+                  <a:srgbClr val="9AA6B8"/>
+                </a:solidFill>
+                <a:latin typeface="Segoe UI"/>
+              </a:rPr>
+              <a:t>Asymchem · Sandwich Site   |   Continuous Hydrogenation Skid</a:t>
+            </a:r>
+          </a:p>
+        </p:txBody>
+      </p:sp>
+      <p:sp>
+        <p:nvSpPr>
+          <p:cNvPr id="20" name="TextBox 19"/>
+          <p:cNvSpPr txBox="1"/>
+          <p:nvPr/>
+        </p:nvSpPr>
+        <p:spPr>
+          <a:xfrm>
+            <a:off x="6949440" y="6446520"/>
+            <a:ext cx="4663440" cy="274320"/>
+          </a:xfrm>
+          <a:prstGeom prst="rect">
+            <a:avLst/>
+          </a:prstGeom>
+          <a:noFill/>
+        </p:spPr>
+        <p:txBody>
+          <a:bodyPr wrap="none">
+            <a:spAutoFit/>
+          </a:bodyPr>
+          <a:lstStyle/>
+          <a:p>
+            <a:pPr algn="r"/>
+            <a:r>
+              <a:rPr sz="900" b="0" i="0">
+                <a:solidFill>
+                  <a:srgbClr val="9AA6B8"/>
+                </a:solidFill>
+                <a:latin typeface="Segoe UI"/>
+              </a:rPr>
+              <a:t>Progress 2026-09-23 ~ 10-21    ·    04 / 08</a:t>
+            </a:r>
+          </a:p>
+        </p:txBody>
+      </p:sp>
+    </p:spTree>
+  </p:cSld>
+  <p:clrMapOvr>
+    <a:masterClrMapping/>
+  </p:clrMapOvr>
+</p:sld>
+</file>
+
+<file path=ppt/slides/slide5.xml><?xml version="1.0" encoding="utf-8"?>
+<p:sld xmlns:a="http://schemas.openxmlformats.org/drawingml/2006/main" xmlns:p="http://schemas.openxmlformats.org/presentationml/2006/main" xmlns:r="http://schemas.openxmlformats.org/officeDocument/2006/relationships">
+  <p:cSld>
+    <p:spTree>
+      <p:nvGrpSpPr>
+        <p:cNvPr id="1" name=""/>
+        <p:cNvGrpSpPr/>
+        <p:nvPr/>
+      </p:nvGrpSpPr>
+      <p:grpSpPr/>
+      <p:sp>
+        <p:nvSpPr>
+          <p:cNvPr id="2" name="Rectangle 1"/>
+          <p:cNvSpPr/>
+          <p:nvPr/>
+        </p:nvSpPr>
+        <p:spPr>
+          <a:xfrm>
+            <a:off x="0" y="0"/>
+            <a:ext cx="12191695" cy="146304"/>
+          </a:xfrm>
+          <a:prstGeom prst="rect">
             <a:avLst/>
           </a:prstGeom>
           <a:solidFill>
@@ -5813,6 +6662,50 @@
       </p:sp>
       <p:sp>
         <p:nvSpPr>
+          <p:cNvPr id="3" name="Rounded Rectangle 2"/>
+          <p:cNvSpPr/>
+          <p:nvPr/>
+        </p:nvSpPr>
+        <p:spPr>
+          <a:xfrm>
+            <a:off x="502920" y="347472"/>
+            <a:ext cx="841248" cy="841248"/>
+          </a:xfrm>
+          <a:prstGeom prst="roundRect">
+            <a:avLst/>
+          </a:prstGeom>
+          <a:solidFill>
+            <a:srgbClr val="DC2626"/>
+          </a:solidFill>
+          <a:ln>
+            <a:noFill/>
+          </a:ln>
+          <a:effectLst/>
+        </p:spPr>
+        <p:style>
+          <a:lnRef idx="1">
+            <a:schemeClr val="accent1"/>
+          </a:lnRef>
+          <a:fillRef idx="3">
+            <a:schemeClr val="accent1"/>
+          </a:fillRef>
+          <a:effectRef idx="2">
+            <a:schemeClr val="accent1"/>
+          </a:effectRef>
+          <a:fontRef idx="minor">
+            <a:schemeClr val="lt1"/>
+          </a:fontRef>
+        </p:style>
+        <p:txBody>
+          <a:bodyPr rtlCol="0" anchor="ctr"/>
+          <a:lstStyle/>
+          <a:p>
+            <a:pPr algn="ctr"/>
+          </a:p>
+        </p:txBody>
+      </p:sp>
+      <p:sp>
+        <p:nvSpPr>
           <p:cNvPr id="4" name="TextBox 3"/>
           <p:cNvSpPr txBox="1"/>
           <p:nvPr/>
@@ -5841,7 +6734,7 @@
                 </a:solidFill>
                 <a:latin typeface="Segoe UI"/>
               </a:rPr>
-              <a:t>04</a:t>
+              <a:t>05</a:t>
             </a:r>
           </a:p>
         </p:txBody>
@@ -7388,7 +8281,7 @@
                 </a:solidFill>
                 <a:latin typeface="Segoe UI"/>
               </a:rPr>
-              <a:t>Progress 2026-09-23 ~ 10-21    ·    04 / 07</a:t>
+              <a:t>Progress 2026-09-23 ~ 10-21    ·    05 / 08</a:t>
             </a:r>
           </a:p>
         </p:txBody>
@@ -7401,7 +8294,7 @@
 </p:sld>
 </file>
 
-<file path=ppt/slides/slide5.xml><?xml version="1.0" encoding="utf-8"?>
+<file path=ppt/slides/slide6.xml><?xml version="1.0" encoding="utf-8"?>
 <p:sld xmlns:a="http://schemas.openxmlformats.org/drawingml/2006/main" xmlns:p="http://schemas.openxmlformats.org/presentationml/2006/main" xmlns:r="http://schemas.openxmlformats.org/officeDocument/2006/relationships">
   <p:cSld>
     <p:spTree>
@@ -7529,7 +8422,7 @@
                 </a:solidFill>
                 <a:latin typeface="Segoe UI"/>
               </a:rPr>
-              <a:t>05</a:t>
+              <a:t>06</a:t>
             </a:r>
           </a:p>
         </p:txBody>
@@ -8576,924 +9469,7 @@
                 </a:solidFill>
                 <a:latin typeface="Segoe UI"/>
               </a:rPr>
-              <a:t>Progress 2026-09-23 ~ 10-21    ·    05 / 07</a:t>
-            </a:r>
-          </a:p>
-        </p:txBody>
-      </p:sp>
-    </p:spTree>
-  </p:cSld>
-  <p:clrMapOvr>
-    <a:masterClrMapping/>
-  </p:clrMapOvr>
-</p:sld>
-</file>
-
-<file path=ppt/slides/slide6.xml><?xml version="1.0" encoding="utf-8"?>
-<p:sld xmlns:a="http://schemas.openxmlformats.org/drawingml/2006/main" xmlns:p="http://schemas.openxmlformats.org/presentationml/2006/main" xmlns:r="http://schemas.openxmlformats.org/officeDocument/2006/relationships">
-  <p:cSld>
-    <p:spTree>
-      <p:nvGrpSpPr>
-        <p:cNvPr id="1" name=""/>
-        <p:cNvGrpSpPr/>
-        <p:nvPr/>
-      </p:nvGrpSpPr>
-      <p:grpSpPr/>
-      <p:sp>
-        <p:nvSpPr>
-          <p:cNvPr id="2" name="Rectangle 1"/>
-          <p:cNvSpPr/>
-          <p:nvPr/>
-        </p:nvSpPr>
-        <p:spPr>
-          <a:xfrm>
-            <a:off x="0" y="0"/>
-            <a:ext cx="12191695" cy="146304"/>
-          </a:xfrm>
-          <a:prstGeom prst="rect">
-            <a:avLst/>
-          </a:prstGeom>
-          <a:solidFill>
-            <a:srgbClr val="7C3AED"/>
-          </a:solidFill>
-          <a:ln>
-            <a:noFill/>
-          </a:ln>
-          <a:effectLst/>
-        </p:spPr>
-        <p:style>
-          <a:lnRef idx="1">
-            <a:schemeClr val="accent1"/>
-          </a:lnRef>
-          <a:fillRef idx="3">
-            <a:schemeClr val="accent1"/>
-          </a:fillRef>
-          <a:effectRef idx="2">
-            <a:schemeClr val="accent1"/>
-          </a:effectRef>
-          <a:fontRef idx="minor">
-            <a:schemeClr val="lt1"/>
-          </a:fontRef>
-        </p:style>
-        <p:txBody>
-          <a:bodyPr rtlCol="0" anchor="ctr"/>
-          <a:lstStyle/>
-          <a:p>
-            <a:pPr algn="ctr"/>
-          </a:p>
-        </p:txBody>
-      </p:sp>
-      <p:sp>
-        <p:nvSpPr>
-          <p:cNvPr id="3" name="Rounded Rectangle 2"/>
-          <p:cNvSpPr/>
-          <p:nvPr/>
-        </p:nvSpPr>
-        <p:spPr>
-          <a:xfrm>
-            <a:off x="502920" y="347472"/>
-            <a:ext cx="841248" cy="841248"/>
-          </a:xfrm>
-          <a:prstGeom prst="roundRect">
-            <a:avLst/>
-          </a:prstGeom>
-          <a:solidFill>
-            <a:srgbClr val="7C3AED"/>
-          </a:solidFill>
-          <a:ln>
-            <a:noFill/>
-          </a:ln>
-          <a:effectLst/>
-        </p:spPr>
-        <p:style>
-          <a:lnRef idx="1">
-            <a:schemeClr val="accent1"/>
-          </a:lnRef>
-          <a:fillRef idx="3">
-            <a:schemeClr val="accent1"/>
-          </a:fillRef>
-          <a:effectRef idx="2">
-            <a:schemeClr val="accent1"/>
-          </a:effectRef>
-          <a:fontRef idx="minor">
-            <a:schemeClr val="lt1"/>
-          </a:fontRef>
-        </p:style>
-        <p:txBody>
-          <a:bodyPr rtlCol="0" anchor="ctr"/>
-          <a:lstStyle/>
-          <a:p>
-            <a:pPr algn="ctr"/>
-          </a:p>
-        </p:txBody>
-      </p:sp>
-      <p:sp>
-        <p:nvSpPr>
-          <p:cNvPr id="4" name="TextBox 3"/>
-          <p:cNvSpPr txBox="1"/>
-          <p:nvPr/>
-        </p:nvSpPr>
-        <p:spPr>
-          <a:xfrm>
-            <a:off x="502920" y="347472"/>
-            <a:ext cx="841248" cy="841248"/>
-          </a:xfrm>
-          <a:prstGeom prst="rect">
-            <a:avLst/>
-          </a:prstGeom>
-          <a:noFill/>
-        </p:spPr>
-        <p:txBody>
-          <a:bodyPr wrap="none" anchor="ctr" lIns="0" rIns="0" tIns="0" bIns="0">
-            <a:spAutoFit/>
-          </a:bodyPr>
-          <a:lstStyle/>
-          <a:p>
-            <a:pPr algn="ctr"/>
-            <a:r>
-              <a:rPr sz="3200" b="1" i="0">
-                <a:solidFill>
-                  <a:srgbClr val="FFFFFF"/>
-                </a:solidFill>
-                <a:latin typeface="Segoe UI"/>
-              </a:rPr>
-              <a:t>06</a:t>
-            </a:r>
-          </a:p>
-        </p:txBody>
-      </p:sp>
-      <p:sp>
-        <p:nvSpPr>
-          <p:cNvPr id="5" name="TextBox 4"/>
-          <p:cNvSpPr txBox="1"/>
-          <p:nvPr/>
-        </p:nvSpPr>
-        <p:spPr>
-          <a:xfrm>
-            <a:off x="1536192" y="365760"/>
-            <a:ext cx="10058400" cy="804672"/>
-          </a:xfrm>
-          <a:prstGeom prst="rect">
-            <a:avLst/>
-          </a:prstGeom>
-          <a:noFill/>
-        </p:spPr>
-        <p:txBody>
-          <a:bodyPr wrap="square" lIns="0" rIns="0" anchor="ctr">
-            <a:spAutoFit/>
-          </a:bodyPr>
-          <a:lstStyle/>
-          <a:p>
-            <a:r>
-              <a:rPr sz="2800" b="1" i="0">
-                <a:solidFill>
-                  <a:srgbClr val="7C3AED"/>
-                </a:solidFill>
-                <a:latin typeface="Segoe UI"/>
-              </a:rPr>
-              <a:t>Decision 2 — Reactor 1 (R24-CR01) at DN65</a:t>
-            </a:r>
-          </a:p>
-          <a:p>
-            <a:pPr>
-              <a:spcBef>
-                <a:spcPts val="100"/>
-              </a:spcBef>
-            </a:pPr>
-            <a:r>
-              <a:rPr sz="1400" b="0" i="0">
-                <a:solidFill>
-                  <a:srgbClr val="8A97AB"/>
-                </a:solidFill>
-                <a:latin typeface="Segoe UI"/>
-              </a:rPr>
-              <a:t>Preliminary decision, 15 October</a:t>
-            </a:r>
-          </a:p>
-        </p:txBody>
-      </p:sp>
-      <p:sp>
-        <p:nvSpPr>
-          <p:cNvPr id="6" name="Rectangle 5"/>
-          <p:cNvSpPr/>
-          <p:nvPr/>
-        </p:nvSpPr>
-        <p:spPr>
-          <a:xfrm>
-            <a:off x="502920" y="1335024"/>
-            <a:ext cx="11183112" cy="13716"/>
-          </a:xfrm>
-          <a:prstGeom prst="rect">
-            <a:avLst/>
-          </a:prstGeom>
-          <a:solidFill>
-            <a:srgbClr val="E3E8F0"/>
-          </a:solidFill>
-          <a:ln>
-            <a:noFill/>
-          </a:ln>
-          <a:effectLst/>
-        </p:spPr>
-        <p:style>
-          <a:lnRef idx="1">
-            <a:schemeClr val="accent1"/>
-          </a:lnRef>
-          <a:fillRef idx="3">
-            <a:schemeClr val="accent1"/>
-          </a:fillRef>
-          <a:effectRef idx="2">
-            <a:schemeClr val="accent1"/>
-          </a:effectRef>
-          <a:fontRef idx="minor">
-            <a:schemeClr val="lt1"/>
-          </a:fontRef>
-        </p:style>
-        <p:txBody>
-          <a:bodyPr rtlCol="0" anchor="ctr"/>
-          <a:lstStyle/>
-          <a:p>
-            <a:pPr algn="ctr"/>
-          </a:p>
-        </p:txBody>
-      </p:sp>
-      <p:sp>
-        <p:nvSpPr>
-          <p:cNvPr id="7" name="Rounded Rectangle 6"/>
-          <p:cNvSpPr/>
-          <p:nvPr/>
-        </p:nvSpPr>
-        <p:spPr>
-          <a:xfrm>
-            <a:off x="502920" y="1481328"/>
-            <a:ext cx="11183112" cy="752983"/>
-          </a:xfrm>
-          <a:prstGeom prst="roundRect">
-            <a:avLst/>
-          </a:prstGeom>
-          <a:solidFill>
-            <a:srgbClr val="F4F7FB"/>
-          </a:solidFill>
-          <a:ln w="12700">
-            <a:solidFill>
-              <a:srgbClr val="E3E8F0"/>
-            </a:solidFill>
-          </a:ln>
-          <a:effectLst/>
-        </p:spPr>
-        <p:style>
-          <a:lnRef idx="1">
-            <a:schemeClr val="accent1"/>
-          </a:lnRef>
-          <a:fillRef idx="3">
-            <a:schemeClr val="accent1"/>
-          </a:fillRef>
-          <a:effectRef idx="2">
-            <a:schemeClr val="accent1"/>
-          </a:effectRef>
-          <a:fontRef idx="minor">
-            <a:schemeClr val="lt1"/>
-          </a:fontRef>
-        </p:style>
-        <p:txBody>
-          <a:bodyPr rtlCol="0" anchor="ctr"/>
-          <a:lstStyle/>
-          <a:p>
-            <a:pPr algn="ctr"/>
-          </a:p>
-        </p:txBody>
-      </p:sp>
-      <p:sp>
-        <p:nvSpPr>
-          <p:cNvPr id="8" name="Rectangle 7"/>
-          <p:cNvSpPr/>
-          <p:nvPr/>
-        </p:nvSpPr>
-        <p:spPr>
-          <a:xfrm>
-            <a:off x="502920" y="1481328"/>
-            <a:ext cx="64008" cy="752983"/>
-          </a:xfrm>
-          <a:prstGeom prst="rect">
-            <a:avLst/>
-          </a:prstGeom>
-          <a:solidFill>
-            <a:srgbClr val="7C3AED"/>
-          </a:solidFill>
-          <a:ln>
-            <a:noFill/>
-          </a:ln>
-          <a:effectLst/>
-        </p:spPr>
-        <p:style>
-          <a:lnRef idx="1">
-            <a:schemeClr val="accent1"/>
-          </a:lnRef>
-          <a:fillRef idx="3">
-            <a:schemeClr val="accent1"/>
-          </a:fillRef>
-          <a:effectRef idx="2">
-            <a:schemeClr val="accent1"/>
-          </a:effectRef>
-          <a:fontRef idx="minor">
-            <a:schemeClr val="lt1"/>
-          </a:fontRef>
-        </p:style>
-        <p:txBody>
-          <a:bodyPr rtlCol="0" anchor="ctr"/>
-          <a:lstStyle/>
-          <a:p>
-            <a:pPr algn="ctr"/>
-          </a:p>
-        </p:txBody>
-      </p:sp>
-      <p:sp>
-        <p:nvSpPr>
-          <p:cNvPr id="9" name="TextBox 8"/>
-          <p:cNvSpPr txBox="1"/>
-          <p:nvPr/>
-        </p:nvSpPr>
-        <p:spPr>
-          <a:xfrm>
-            <a:off x="749808" y="1545336"/>
-            <a:ext cx="10744200" cy="661543"/>
-          </a:xfrm>
-          <a:prstGeom prst="rect">
-            <a:avLst/>
-          </a:prstGeom>
-          <a:noFill/>
-        </p:spPr>
-        <p:txBody>
-          <a:bodyPr wrap="square" lIns="0" rIns="0" tIns="0" bIns="0"/>
-          <a:lstStyle/>
-          <a:p>
-            <a:r>
-              <a:rPr sz="1600" b="1" i="0">
-                <a:solidFill>
-                  <a:srgbClr val="1E2B3A"/>
-                </a:solidFill>
-                <a:latin typeface="Segoe UI"/>
-              </a:rPr>
-              <a:t>R24-CR01 goes to DN65 — the same diameter as Reactors 2 and 3.</a:t>
-            </a:r>
-          </a:p>
-          <a:p>
-            <a:pPr>
-              <a:spcBef>
-                <a:spcPts val="400"/>
-              </a:spcBef>
-            </a:pPr>
-            <a:r>
-              <a:rPr sz="1300" b="0" i="0">
-                <a:solidFill>
-                  <a:srgbClr val="94A3B8"/>
-                </a:solidFill>
-                <a:latin typeface="Segoe UI"/>
-              </a:rPr>
-              <a:t>–  </a:t>
-            </a:r>
-            <a:r>
-              <a:rPr sz="1300" b="0" i="0">
-                <a:solidFill>
-                  <a:srgbClr val="5B6B80"/>
-                </a:solidFill>
-                <a:latin typeface="Segoe UI"/>
-              </a:rPr>
-              <a:t>Datasheet basis: 3.5 L and 0.23 m² heat-transfer area (DN80 was 5.1 L and 0.27 m²).</a:t>
-            </a:r>
-          </a:p>
-        </p:txBody>
-      </p:sp>
-      <p:sp>
-        <p:nvSpPr>
-          <p:cNvPr id="10" name="Rounded Rectangle 9"/>
-          <p:cNvSpPr/>
-          <p:nvPr/>
-        </p:nvSpPr>
-        <p:spPr>
-          <a:xfrm>
-            <a:off x="502920" y="2325751"/>
-            <a:ext cx="11183112" cy="1275461"/>
-          </a:xfrm>
-          <a:prstGeom prst="roundRect">
-            <a:avLst/>
-          </a:prstGeom>
-          <a:solidFill>
-            <a:srgbClr val="F4F7FB"/>
-          </a:solidFill>
-          <a:ln w="12700">
-            <a:solidFill>
-              <a:srgbClr val="E3E8F0"/>
-            </a:solidFill>
-          </a:ln>
-          <a:effectLst/>
-        </p:spPr>
-        <p:style>
-          <a:lnRef idx="1">
-            <a:schemeClr val="accent1"/>
-          </a:lnRef>
-          <a:fillRef idx="3">
-            <a:schemeClr val="accent1"/>
-          </a:fillRef>
-          <a:effectRef idx="2">
-            <a:schemeClr val="accent1"/>
-          </a:effectRef>
-          <a:fontRef idx="minor">
-            <a:schemeClr val="lt1"/>
-          </a:fontRef>
-        </p:style>
-        <p:txBody>
-          <a:bodyPr rtlCol="0" anchor="ctr"/>
-          <a:lstStyle/>
-          <a:p>
-            <a:pPr algn="ctr"/>
-          </a:p>
-        </p:txBody>
-      </p:sp>
-      <p:sp>
-        <p:nvSpPr>
-          <p:cNvPr id="11" name="Rectangle 10"/>
-          <p:cNvSpPr/>
-          <p:nvPr/>
-        </p:nvSpPr>
-        <p:spPr>
-          <a:xfrm>
-            <a:off x="502920" y="2325751"/>
-            <a:ext cx="64008" cy="1275461"/>
-          </a:xfrm>
-          <a:prstGeom prst="rect">
-            <a:avLst/>
-          </a:prstGeom>
-          <a:solidFill>
-            <a:srgbClr val="7C3AED"/>
-          </a:solidFill>
-          <a:ln>
-            <a:noFill/>
-          </a:ln>
-          <a:effectLst/>
-        </p:spPr>
-        <p:style>
-          <a:lnRef idx="1">
-            <a:schemeClr val="accent1"/>
-          </a:lnRef>
-          <a:fillRef idx="3">
-            <a:schemeClr val="accent1"/>
-          </a:fillRef>
-          <a:effectRef idx="2">
-            <a:schemeClr val="accent1"/>
-          </a:effectRef>
-          <a:fontRef idx="minor">
-            <a:schemeClr val="lt1"/>
-          </a:fontRef>
-        </p:style>
-        <p:txBody>
-          <a:bodyPr rtlCol="0" anchor="ctr"/>
-          <a:lstStyle/>
-          <a:p>
-            <a:pPr algn="ctr"/>
-          </a:p>
-        </p:txBody>
-      </p:sp>
-      <p:sp>
-        <p:nvSpPr>
-          <p:cNvPr id="12" name="TextBox 11"/>
-          <p:cNvSpPr txBox="1"/>
-          <p:nvPr/>
-        </p:nvSpPr>
-        <p:spPr>
-          <a:xfrm>
-            <a:off x="749808" y="2389759"/>
-            <a:ext cx="10744200" cy="1184021"/>
-          </a:xfrm>
-          <a:prstGeom prst="rect">
-            <a:avLst/>
-          </a:prstGeom>
-          <a:noFill/>
-        </p:spPr>
-        <p:txBody>
-          <a:bodyPr wrap="square" lIns="0" rIns="0" tIns="0" bIns="0"/>
-          <a:lstStyle/>
-          <a:p>
-            <a:r>
-              <a:rPr sz="1600" b="1" i="0">
-                <a:solidFill>
-                  <a:srgbClr val="1E2B3A"/>
-                </a:solidFill>
-                <a:latin typeface="Segoe UI"/>
-              </a:rPr>
-              <a:t>Catalyst charging decides it.</a:t>
-            </a:r>
-          </a:p>
-          <a:p>
-            <a:pPr>
-              <a:spcBef>
-                <a:spcPts val="400"/>
-              </a:spcBef>
-            </a:pPr>
-            <a:r>
-              <a:rPr sz="1300" b="0" i="0">
-                <a:solidFill>
-                  <a:srgbClr val="94A3B8"/>
-                </a:solidFill>
-                <a:latin typeface="Segoe UI"/>
-              </a:rPr>
-              <a:t>–  </a:t>
-            </a:r>
-            <a:r>
-              <a:rPr sz="1300" b="0" i="0">
-                <a:solidFill>
-                  <a:srgbClr val="5B6B80"/>
-                </a:solidFill>
-                <a:latin typeface="Segoe UI"/>
-              </a:rPr>
-              <a:t>DN50: the largest catalyst charge and discharge nozzle is 3/4"; the smallest bottom discharge valve is 3/4".</a:t>
-            </a:r>
-          </a:p>
-          <a:p>
-            <a:pPr>
-              <a:spcBef>
-                <a:spcPts val="400"/>
-              </a:spcBef>
-            </a:pPr>
-            <a:r>
-              <a:rPr sz="1300" b="0" i="0">
-                <a:solidFill>
-                  <a:srgbClr val="94A3B8"/>
-                </a:solidFill>
-                <a:latin typeface="Segoe UI"/>
-              </a:rPr>
-              <a:t>–  </a:t>
-            </a:r>
-            <a:r>
-              <a:rPr sz="1300" b="0" i="0">
-                <a:solidFill>
-                  <a:srgbClr val="5B6B80"/>
-                </a:solidFill>
-                <a:latin typeface="Segoe UI"/>
-              </a:rPr>
-              <a:t>SW view (8 Oct): 1/2" would not take the catalyst; 3/4" would be difficult.</a:t>
-            </a:r>
-          </a:p>
-          <a:p>
-            <a:pPr>
-              <a:spcBef>
-                <a:spcPts val="400"/>
-              </a:spcBef>
-            </a:pPr>
-            <a:r>
-              <a:rPr sz="1300" b="0" i="0">
-                <a:solidFill>
-                  <a:srgbClr val="94A3B8"/>
-                </a:solidFill>
-                <a:latin typeface="Segoe UI"/>
-              </a:rPr>
-              <a:t>–  </a:t>
-            </a:r>
-            <a:r>
-              <a:rPr sz="1300" b="0" i="0">
-                <a:solidFill>
-                  <a:srgbClr val="5B6B80"/>
-                </a:solidFill>
-                <a:latin typeface="Segoe UI"/>
-              </a:rPr>
-              <a:t>DN65 keeps the 1" charge and discharge nozzles already designed.</a:t>
-            </a:r>
-          </a:p>
-        </p:txBody>
-      </p:sp>
-      <p:sp>
-        <p:nvSpPr>
-          <p:cNvPr id="13" name="Rounded Rectangle 12"/>
-          <p:cNvSpPr/>
-          <p:nvPr/>
-        </p:nvSpPr>
-        <p:spPr>
-          <a:xfrm>
-            <a:off x="502920" y="3692652"/>
-            <a:ext cx="11183112" cy="1006982"/>
-          </a:xfrm>
-          <a:prstGeom prst="roundRect">
-            <a:avLst/>
-          </a:prstGeom>
-          <a:solidFill>
-            <a:srgbClr val="F4F7FB"/>
-          </a:solidFill>
-          <a:ln w="12700">
-            <a:solidFill>
-              <a:srgbClr val="E3E8F0"/>
-            </a:solidFill>
-          </a:ln>
-          <a:effectLst/>
-        </p:spPr>
-        <p:style>
-          <a:lnRef idx="1">
-            <a:schemeClr val="accent1"/>
-          </a:lnRef>
-          <a:fillRef idx="3">
-            <a:schemeClr val="accent1"/>
-          </a:fillRef>
-          <a:effectRef idx="2">
-            <a:schemeClr val="accent1"/>
-          </a:effectRef>
-          <a:fontRef idx="minor">
-            <a:schemeClr val="lt1"/>
-          </a:fontRef>
-        </p:style>
-        <p:txBody>
-          <a:bodyPr rtlCol="0" anchor="ctr"/>
-          <a:lstStyle/>
-          <a:p>
-            <a:pPr algn="ctr"/>
-          </a:p>
-        </p:txBody>
-      </p:sp>
-      <p:sp>
-        <p:nvSpPr>
-          <p:cNvPr id="14" name="Rectangle 13"/>
-          <p:cNvSpPr/>
-          <p:nvPr/>
-        </p:nvSpPr>
-        <p:spPr>
-          <a:xfrm>
-            <a:off x="502920" y="3692652"/>
-            <a:ext cx="64008" cy="1006982"/>
-          </a:xfrm>
-          <a:prstGeom prst="rect">
-            <a:avLst/>
-          </a:prstGeom>
-          <a:solidFill>
-            <a:srgbClr val="7C3AED"/>
-          </a:solidFill>
-          <a:ln>
-            <a:noFill/>
-          </a:ln>
-          <a:effectLst/>
-        </p:spPr>
-        <p:style>
-          <a:lnRef idx="1">
-            <a:schemeClr val="accent1"/>
-          </a:lnRef>
-          <a:fillRef idx="3">
-            <a:schemeClr val="accent1"/>
-          </a:fillRef>
-          <a:effectRef idx="2">
-            <a:schemeClr val="accent1"/>
-          </a:effectRef>
-          <a:fontRef idx="minor">
-            <a:schemeClr val="lt1"/>
-          </a:fontRef>
-        </p:style>
-        <p:txBody>
-          <a:bodyPr rtlCol="0" anchor="ctr"/>
-          <a:lstStyle/>
-          <a:p>
-            <a:pPr algn="ctr"/>
-          </a:p>
-        </p:txBody>
-      </p:sp>
-      <p:sp>
-        <p:nvSpPr>
-          <p:cNvPr id="15" name="TextBox 14"/>
-          <p:cNvSpPr txBox="1"/>
-          <p:nvPr/>
-        </p:nvSpPr>
-        <p:spPr>
-          <a:xfrm>
-            <a:off x="749808" y="3756660"/>
-            <a:ext cx="10744200" cy="915542"/>
-          </a:xfrm>
-          <a:prstGeom prst="rect">
-            <a:avLst/>
-          </a:prstGeom>
-          <a:noFill/>
-        </p:spPr>
-        <p:txBody>
-          <a:bodyPr wrap="square" lIns="0" rIns="0" tIns="0" bIns="0"/>
-          <a:lstStyle/>
-          <a:p>
-            <a:r>
-              <a:rPr sz="1600" b="1" i="0">
-                <a:solidFill>
-                  <a:srgbClr val="1E2B3A"/>
-                </a:solidFill>
-                <a:latin typeface="Segoe UI"/>
-              </a:rPr>
-              <a:t>Temperature: R&amp;D measured about 5–7 °C rise at DN40 and a 15–18 °C hot spot at DN65.  There is no DN50 data.</a:t>
-            </a:r>
-          </a:p>
-          <a:p>
-            <a:pPr>
-              <a:spcBef>
-                <a:spcPts val="400"/>
-              </a:spcBef>
-            </a:pPr>
-            <a:r>
-              <a:rPr sz="1300" b="0" i="0">
-                <a:solidFill>
-                  <a:srgbClr val="94A3B8"/>
-                </a:solidFill>
-                <a:latin typeface="Segoe UI"/>
-              </a:rPr>
-              <a:t>–  </a:t>
-            </a:r>
-            <a:r>
-              <a:rPr sz="1300" b="0" i="0">
-                <a:solidFill>
-                  <a:srgbClr val="5B6B80"/>
-                </a:solidFill>
-                <a:latin typeface="Segoe UI"/>
-              </a:rPr>
-              <a:t>At DN65 the hot spot can be controlled by diluting the catalyst bed with inert material at loading.</a:t>
-            </a:r>
-          </a:p>
-        </p:txBody>
-      </p:sp>
-      <p:sp>
-        <p:nvSpPr>
-          <p:cNvPr id="16" name="Rounded Rectangle 15"/>
-          <p:cNvSpPr/>
-          <p:nvPr/>
-        </p:nvSpPr>
-        <p:spPr>
-          <a:xfrm>
-            <a:off x="502920" y="4791074"/>
-            <a:ext cx="11183112" cy="745744"/>
-          </a:xfrm>
-          <a:prstGeom prst="roundRect">
-            <a:avLst/>
-          </a:prstGeom>
-          <a:solidFill>
-            <a:srgbClr val="F4F7FB"/>
-          </a:solidFill>
-          <a:ln w="12700">
-            <a:solidFill>
-              <a:srgbClr val="E3E8F0"/>
-            </a:solidFill>
-          </a:ln>
-          <a:effectLst/>
-        </p:spPr>
-        <p:style>
-          <a:lnRef idx="1">
-            <a:schemeClr val="accent1"/>
-          </a:lnRef>
-          <a:fillRef idx="3">
-            <a:schemeClr val="accent1"/>
-          </a:fillRef>
-          <a:effectRef idx="2">
-            <a:schemeClr val="accent1"/>
-          </a:effectRef>
-          <a:fontRef idx="minor">
-            <a:schemeClr val="lt1"/>
-          </a:fontRef>
-        </p:style>
-        <p:txBody>
-          <a:bodyPr rtlCol="0" anchor="ctr"/>
-          <a:lstStyle/>
-          <a:p>
-            <a:pPr algn="ctr"/>
-          </a:p>
-        </p:txBody>
-      </p:sp>
-      <p:sp>
-        <p:nvSpPr>
-          <p:cNvPr id="17" name="Rectangle 16"/>
-          <p:cNvSpPr/>
-          <p:nvPr/>
-        </p:nvSpPr>
-        <p:spPr>
-          <a:xfrm>
-            <a:off x="502920" y="4791074"/>
-            <a:ext cx="64008" cy="745744"/>
-          </a:xfrm>
-          <a:prstGeom prst="rect">
-            <a:avLst/>
-          </a:prstGeom>
-          <a:solidFill>
-            <a:srgbClr val="7C3AED"/>
-          </a:solidFill>
-          <a:ln>
-            <a:noFill/>
-          </a:ln>
-          <a:effectLst/>
-        </p:spPr>
-        <p:style>
-          <a:lnRef idx="1">
-            <a:schemeClr val="accent1"/>
-          </a:lnRef>
-          <a:fillRef idx="3">
-            <a:schemeClr val="accent1"/>
-          </a:fillRef>
-          <a:effectRef idx="2">
-            <a:schemeClr val="accent1"/>
-          </a:effectRef>
-          <a:fontRef idx="minor">
-            <a:schemeClr val="lt1"/>
-          </a:fontRef>
-        </p:style>
-        <p:txBody>
-          <a:bodyPr rtlCol="0" anchor="ctr"/>
-          <a:lstStyle/>
-          <a:p>
-            <a:pPr algn="ctr"/>
-          </a:p>
-        </p:txBody>
-      </p:sp>
-      <p:sp>
-        <p:nvSpPr>
-          <p:cNvPr id="18" name="TextBox 17"/>
-          <p:cNvSpPr txBox="1"/>
-          <p:nvPr/>
-        </p:nvSpPr>
-        <p:spPr>
-          <a:xfrm>
-            <a:off x="749808" y="4855082"/>
-            <a:ext cx="10744200" cy="654304"/>
-          </a:xfrm>
-          <a:prstGeom prst="rect">
-            <a:avLst/>
-          </a:prstGeom>
-          <a:noFill/>
-        </p:spPr>
-        <p:txBody>
-          <a:bodyPr wrap="square" lIns="0" rIns="0" tIns="0" bIns="0"/>
-          <a:lstStyle/>
-          <a:p>
-            <a:r>
-              <a:rPr sz="1600" b="1" i="0">
-                <a:solidFill>
-                  <a:srgbClr val="1E2B3A"/>
-                </a:solidFill>
-                <a:latin typeface="Segoe UI"/>
-              </a:rPr>
-              <a:t>Fits the skid height; DN50 would need a longer column for the same volume.  PFD and mass balance are unchanged; the DN65 relief calculation already exists.</a:t>
-            </a:r>
-          </a:p>
-        </p:txBody>
-      </p:sp>
-      <p:sp>
-        <p:nvSpPr>
-          <p:cNvPr id="19" name="TextBox 18"/>
-          <p:cNvSpPr txBox="1"/>
-          <p:nvPr/>
-        </p:nvSpPr>
-        <p:spPr>
-          <a:xfrm>
-            <a:off x="548640" y="6446520"/>
-            <a:ext cx="6583680" cy="274320"/>
-          </a:xfrm>
-          <a:prstGeom prst="rect">
-            <a:avLst/>
-          </a:prstGeom>
-          <a:noFill/>
-        </p:spPr>
-        <p:txBody>
-          <a:bodyPr wrap="none">
-            <a:spAutoFit/>
-          </a:bodyPr>
-          <a:lstStyle/>
-          <a:p>
-            <a:r>
-              <a:rPr sz="900" b="0" i="0">
-                <a:solidFill>
-                  <a:srgbClr val="9AA6B8"/>
-                </a:solidFill>
-                <a:latin typeface="Segoe UI"/>
-              </a:rPr>
-              <a:t>Asymchem · Sandwich Site   |   Continuous Hydrogenation Skid</a:t>
-            </a:r>
-          </a:p>
-        </p:txBody>
-      </p:sp>
-      <p:sp>
-        <p:nvSpPr>
-          <p:cNvPr id="20" name="TextBox 19"/>
-          <p:cNvSpPr txBox="1"/>
-          <p:nvPr/>
-        </p:nvSpPr>
-        <p:spPr>
-          <a:xfrm>
-            <a:off x="6949440" y="6446520"/>
-            <a:ext cx="4663440" cy="274320"/>
-          </a:xfrm>
-          <a:prstGeom prst="rect">
-            <a:avLst/>
-          </a:prstGeom>
-          <a:noFill/>
-        </p:spPr>
-        <p:txBody>
-          <a:bodyPr wrap="none">
-            <a:spAutoFit/>
-          </a:bodyPr>
-          <a:lstStyle/>
-          <a:p>
-            <a:pPr algn="r"/>
-            <a:r>
-              <a:rPr sz="900" b="0" i="0">
-                <a:solidFill>
-                  <a:srgbClr val="9AA6B8"/>
-                </a:solidFill>
-                <a:latin typeface="Segoe UI"/>
-              </a:rPr>
-              <a:t>Progress 2026-09-23 ~ 10-21    ·    06 / 07</a:t>
+              <a:t>Progress 2026-09-23 ~ 10-21    ·    06 / 08</a:t>
             </a:r>
           </a:p>
         </p:txBody>
@@ -9531,7 +9507,7 @@
             <a:avLst/>
           </a:prstGeom>
           <a:solidFill>
-            <a:srgbClr val="0E9AA7"/>
+            <a:srgbClr val="7C3AED"/>
           </a:solidFill>
           <a:ln>
             <a:noFill/>
@@ -9572,6 +9548,879 @@
             <a:ext cx="841248" cy="841248"/>
           </a:xfrm>
           <a:prstGeom prst="roundRect">
+            <a:avLst/>
+          </a:prstGeom>
+          <a:solidFill>
+            <a:srgbClr val="7C3AED"/>
+          </a:solidFill>
+          <a:ln>
+            <a:noFill/>
+          </a:ln>
+          <a:effectLst/>
+        </p:spPr>
+        <p:style>
+          <a:lnRef idx="1">
+            <a:schemeClr val="accent1"/>
+          </a:lnRef>
+          <a:fillRef idx="3">
+            <a:schemeClr val="accent1"/>
+          </a:fillRef>
+          <a:effectRef idx="2">
+            <a:schemeClr val="accent1"/>
+          </a:effectRef>
+          <a:fontRef idx="minor">
+            <a:schemeClr val="lt1"/>
+          </a:fontRef>
+        </p:style>
+        <p:txBody>
+          <a:bodyPr rtlCol="0" anchor="ctr"/>
+          <a:lstStyle/>
+          <a:p>
+            <a:pPr algn="ctr"/>
+          </a:p>
+        </p:txBody>
+      </p:sp>
+      <p:sp>
+        <p:nvSpPr>
+          <p:cNvPr id="4" name="TextBox 3"/>
+          <p:cNvSpPr txBox="1"/>
+          <p:nvPr/>
+        </p:nvSpPr>
+        <p:spPr>
+          <a:xfrm>
+            <a:off x="502920" y="347472"/>
+            <a:ext cx="841248" cy="841248"/>
+          </a:xfrm>
+          <a:prstGeom prst="rect">
+            <a:avLst/>
+          </a:prstGeom>
+          <a:noFill/>
+        </p:spPr>
+        <p:txBody>
+          <a:bodyPr wrap="none" anchor="ctr" lIns="0" rIns="0" tIns="0" bIns="0">
+            <a:spAutoFit/>
+          </a:bodyPr>
+          <a:lstStyle/>
+          <a:p>
+            <a:pPr algn="ctr"/>
+            <a:r>
+              <a:rPr sz="3200" b="1" i="0">
+                <a:solidFill>
+                  <a:srgbClr val="FFFFFF"/>
+                </a:solidFill>
+                <a:latin typeface="Segoe UI"/>
+              </a:rPr>
+              <a:t>07</a:t>
+            </a:r>
+          </a:p>
+        </p:txBody>
+      </p:sp>
+      <p:sp>
+        <p:nvSpPr>
+          <p:cNvPr id="5" name="TextBox 4"/>
+          <p:cNvSpPr txBox="1"/>
+          <p:nvPr/>
+        </p:nvSpPr>
+        <p:spPr>
+          <a:xfrm>
+            <a:off x="1536192" y="365760"/>
+            <a:ext cx="10058400" cy="804672"/>
+          </a:xfrm>
+          <a:prstGeom prst="rect">
+            <a:avLst/>
+          </a:prstGeom>
+          <a:noFill/>
+        </p:spPr>
+        <p:txBody>
+          <a:bodyPr wrap="square" lIns="0" rIns="0" anchor="ctr">
+            <a:spAutoFit/>
+          </a:bodyPr>
+          <a:lstStyle/>
+          <a:p>
+            <a:r>
+              <a:rPr sz="2800" b="1" i="0">
+                <a:solidFill>
+                  <a:srgbClr val="7C3AED"/>
+                </a:solidFill>
+                <a:latin typeface="Segoe UI"/>
+              </a:rPr>
+              <a:t>Decision 2 — Reactor 1 (R24-CR01) at DN65</a:t>
+            </a:r>
+          </a:p>
+          <a:p>
+            <a:pPr>
+              <a:spcBef>
+                <a:spcPts val="100"/>
+              </a:spcBef>
+            </a:pPr>
+            <a:r>
+              <a:rPr sz="1400" b="0" i="0">
+                <a:solidFill>
+                  <a:srgbClr val="8A97AB"/>
+                </a:solidFill>
+                <a:latin typeface="Segoe UI"/>
+              </a:rPr>
+              <a:t>Preliminary decision, 15 October</a:t>
+            </a:r>
+          </a:p>
+        </p:txBody>
+      </p:sp>
+      <p:sp>
+        <p:nvSpPr>
+          <p:cNvPr id="6" name="Rectangle 5"/>
+          <p:cNvSpPr/>
+          <p:nvPr/>
+        </p:nvSpPr>
+        <p:spPr>
+          <a:xfrm>
+            <a:off x="502920" y="1335024"/>
+            <a:ext cx="11183112" cy="13716"/>
+          </a:xfrm>
+          <a:prstGeom prst="rect">
+            <a:avLst/>
+          </a:prstGeom>
+          <a:solidFill>
+            <a:srgbClr val="E3E8F0"/>
+          </a:solidFill>
+          <a:ln>
+            <a:noFill/>
+          </a:ln>
+          <a:effectLst/>
+        </p:spPr>
+        <p:style>
+          <a:lnRef idx="1">
+            <a:schemeClr val="accent1"/>
+          </a:lnRef>
+          <a:fillRef idx="3">
+            <a:schemeClr val="accent1"/>
+          </a:fillRef>
+          <a:effectRef idx="2">
+            <a:schemeClr val="accent1"/>
+          </a:effectRef>
+          <a:fontRef idx="minor">
+            <a:schemeClr val="lt1"/>
+          </a:fontRef>
+        </p:style>
+        <p:txBody>
+          <a:bodyPr rtlCol="0" anchor="ctr"/>
+          <a:lstStyle/>
+          <a:p>
+            <a:pPr algn="ctr"/>
+          </a:p>
+        </p:txBody>
+      </p:sp>
+      <p:sp>
+        <p:nvSpPr>
+          <p:cNvPr id="7" name="Rounded Rectangle 6"/>
+          <p:cNvSpPr/>
+          <p:nvPr/>
+        </p:nvSpPr>
+        <p:spPr>
+          <a:xfrm>
+            <a:off x="502920" y="1481328"/>
+            <a:ext cx="11183112" cy="752983"/>
+          </a:xfrm>
+          <a:prstGeom prst="roundRect">
+            <a:avLst/>
+          </a:prstGeom>
+          <a:solidFill>
+            <a:srgbClr val="F4F7FB"/>
+          </a:solidFill>
+          <a:ln w="12700">
+            <a:solidFill>
+              <a:srgbClr val="E3E8F0"/>
+            </a:solidFill>
+          </a:ln>
+          <a:effectLst/>
+        </p:spPr>
+        <p:style>
+          <a:lnRef idx="1">
+            <a:schemeClr val="accent1"/>
+          </a:lnRef>
+          <a:fillRef idx="3">
+            <a:schemeClr val="accent1"/>
+          </a:fillRef>
+          <a:effectRef idx="2">
+            <a:schemeClr val="accent1"/>
+          </a:effectRef>
+          <a:fontRef idx="minor">
+            <a:schemeClr val="lt1"/>
+          </a:fontRef>
+        </p:style>
+        <p:txBody>
+          <a:bodyPr rtlCol="0" anchor="ctr"/>
+          <a:lstStyle/>
+          <a:p>
+            <a:pPr algn="ctr"/>
+          </a:p>
+        </p:txBody>
+      </p:sp>
+      <p:sp>
+        <p:nvSpPr>
+          <p:cNvPr id="8" name="Rectangle 7"/>
+          <p:cNvSpPr/>
+          <p:nvPr/>
+        </p:nvSpPr>
+        <p:spPr>
+          <a:xfrm>
+            <a:off x="502920" y="1481328"/>
+            <a:ext cx="64008" cy="752983"/>
+          </a:xfrm>
+          <a:prstGeom prst="rect">
+            <a:avLst/>
+          </a:prstGeom>
+          <a:solidFill>
+            <a:srgbClr val="7C3AED"/>
+          </a:solidFill>
+          <a:ln>
+            <a:noFill/>
+          </a:ln>
+          <a:effectLst/>
+        </p:spPr>
+        <p:style>
+          <a:lnRef idx="1">
+            <a:schemeClr val="accent1"/>
+          </a:lnRef>
+          <a:fillRef idx="3">
+            <a:schemeClr val="accent1"/>
+          </a:fillRef>
+          <a:effectRef idx="2">
+            <a:schemeClr val="accent1"/>
+          </a:effectRef>
+          <a:fontRef idx="minor">
+            <a:schemeClr val="lt1"/>
+          </a:fontRef>
+        </p:style>
+        <p:txBody>
+          <a:bodyPr rtlCol="0" anchor="ctr"/>
+          <a:lstStyle/>
+          <a:p>
+            <a:pPr algn="ctr"/>
+          </a:p>
+        </p:txBody>
+      </p:sp>
+      <p:sp>
+        <p:nvSpPr>
+          <p:cNvPr id="9" name="TextBox 8"/>
+          <p:cNvSpPr txBox="1"/>
+          <p:nvPr/>
+        </p:nvSpPr>
+        <p:spPr>
+          <a:xfrm>
+            <a:off x="749808" y="1545336"/>
+            <a:ext cx="10744200" cy="661543"/>
+          </a:xfrm>
+          <a:prstGeom prst="rect">
+            <a:avLst/>
+          </a:prstGeom>
+          <a:noFill/>
+        </p:spPr>
+        <p:txBody>
+          <a:bodyPr wrap="square" lIns="0" rIns="0" tIns="0" bIns="0"/>
+          <a:lstStyle/>
+          <a:p>
+            <a:r>
+              <a:rPr sz="1600" b="1" i="0">
+                <a:solidFill>
+                  <a:srgbClr val="1E2B3A"/>
+                </a:solidFill>
+                <a:latin typeface="Segoe UI"/>
+              </a:rPr>
+              <a:t>R24-CR01 goes to DN65 — the same diameter as Reactors 2 and 3.</a:t>
+            </a:r>
+          </a:p>
+          <a:p>
+            <a:pPr>
+              <a:spcBef>
+                <a:spcPts val="400"/>
+              </a:spcBef>
+            </a:pPr>
+            <a:r>
+              <a:rPr sz="1300" b="0" i="0">
+                <a:solidFill>
+                  <a:srgbClr val="94A3B8"/>
+                </a:solidFill>
+                <a:latin typeface="Segoe UI"/>
+              </a:rPr>
+              <a:t>–  </a:t>
+            </a:r>
+            <a:r>
+              <a:rPr sz="1300" b="0" i="0">
+                <a:solidFill>
+                  <a:srgbClr val="5B6B80"/>
+                </a:solidFill>
+                <a:latin typeface="Segoe UI"/>
+              </a:rPr>
+              <a:t>Datasheet basis: 3.5 L and 0.23 m² heat-transfer area (DN80 was 5.1 L and 0.27 m²).</a:t>
+            </a:r>
+          </a:p>
+        </p:txBody>
+      </p:sp>
+      <p:sp>
+        <p:nvSpPr>
+          <p:cNvPr id="10" name="Rounded Rectangle 9"/>
+          <p:cNvSpPr/>
+          <p:nvPr/>
+        </p:nvSpPr>
+        <p:spPr>
+          <a:xfrm>
+            <a:off x="502920" y="2325751"/>
+            <a:ext cx="11183112" cy="1275461"/>
+          </a:xfrm>
+          <a:prstGeom prst="roundRect">
+            <a:avLst/>
+          </a:prstGeom>
+          <a:solidFill>
+            <a:srgbClr val="F4F7FB"/>
+          </a:solidFill>
+          <a:ln w="12700">
+            <a:solidFill>
+              <a:srgbClr val="E3E8F0"/>
+            </a:solidFill>
+          </a:ln>
+          <a:effectLst/>
+        </p:spPr>
+        <p:style>
+          <a:lnRef idx="1">
+            <a:schemeClr val="accent1"/>
+          </a:lnRef>
+          <a:fillRef idx="3">
+            <a:schemeClr val="accent1"/>
+          </a:fillRef>
+          <a:effectRef idx="2">
+            <a:schemeClr val="accent1"/>
+          </a:effectRef>
+          <a:fontRef idx="minor">
+            <a:schemeClr val="lt1"/>
+          </a:fontRef>
+        </p:style>
+        <p:txBody>
+          <a:bodyPr rtlCol="0" anchor="ctr"/>
+          <a:lstStyle/>
+          <a:p>
+            <a:pPr algn="ctr"/>
+          </a:p>
+        </p:txBody>
+      </p:sp>
+      <p:sp>
+        <p:nvSpPr>
+          <p:cNvPr id="11" name="Rectangle 10"/>
+          <p:cNvSpPr/>
+          <p:nvPr/>
+        </p:nvSpPr>
+        <p:spPr>
+          <a:xfrm>
+            <a:off x="502920" y="2325751"/>
+            <a:ext cx="64008" cy="1275461"/>
+          </a:xfrm>
+          <a:prstGeom prst="rect">
+            <a:avLst/>
+          </a:prstGeom>
+          <a:solidFill>
+            <a:srgbClr val="7C3AED"/>
+          </a:solidFill>
+          <a:ln>
+            <a:noFill/>
+          </a:ln>
+          <a:effectLst/>
+        </p:spPr>
+        <p:style>
+          <a:lnRef idx="1">
+            <a:schemeClr val="accent1"/>
+          </a:lnRef>
+          <a:fillRef idx="3">
+            <a:schemeClr val="accent1"/>
+          </a:fillRef>
+          <a:effectRef idx="2">
+            <a:schemeClr val="accent1"/>
+          </a:effectRef>
+          <a:fontRef idx="minor">
+            <a:schemeClr val="lt1"/>
+          </a:fontRef>
+        </p:style>
+        <p:txBody>
+          <a:bodyPr rtlCol="0" anchor="ctr"/>
+          <a:lstStyle/>
+          <a:p>
+            <a:pPr algn="ctr"/>
+          </a:p>
+        </p:txBody>
+      </p:sp>
+      <p:sp>
+        <p:nvSpPr>
+          <p:cNvPr id="12" name="TextBox 11"/>
+          <p:cNvSpPr txBox="1"/>
+          <p:nvPr/>
+        </p:nvSpPr>
+        <p:spPr>
+          <a:xfrm>
+            <a:off x="749808" y="2389759"/>
+            <a:ext cx="10744200" cy="1184021"/>
+          </a:xfrm>
+          <a:prstGeom prst="rect">
+            <a:avLst/>
+          </a:prstGeom>
+          <a:noFill/>
+        </p:spPr>
+        <p:txBody>
+          <a:bodyPr wrap="square" lIns="0" rIns="0" tIns="0" bIns="0"/>
+          <a:lstStyle/>
+          <a:p>
+            <a:r>
+              <a:rPr sz="1600" b="1" i="0">
+                <a:solidFill>
+                  <a:srgbClr val="1E2B3A"/>
+                </a:solidFill>
+                <a:latin typeface="Segoe UI"/>
+              </a:rPr>
+              <a:t>Catalyst charging decides it.</a:t>
+            </a:r>
+          </a:p>
+          <a:p>
+            <a:pPr>
+              <a:spcBef>
+                <a:spcPts val="400"/>
+              </a:spcBef>
+            </a:pPr>
+            <a:r>
+              <a:rPr sz="1300" b="0" i="0">
+                <a:solidFill>
+                  <a:srgbClr val="94A3B8"/>
+                </a:solidFill>
+                <a:latin typeface="Segoe UI"/>
+              </a:rPr>
+              <a:t>–  </a:t>
+            </a:r>
+            <a:r>
+              <a:rPr sz="1300" b="0" i="0">
+                <a:solidFill>
+                  <a:srgbClr val="5B6B80"/>
+                </a:solidFill>
+                <a:latin typeface="Segoe UI"/>
+              </a:rPr>
+              <a:t>DN50: the largest catalyst charge and discharge nozzle is 3/4"; the smallest bottom discharge valve is 3/4".</a:t>
+            </a:r>
+          </a:p>
+          <a:p>
+            <a:pPr>
+              <a:spcBef>
+                <a:spcPts val="400"/>
+              </a:spcBef>
+            </a:pPr>
+            <a:r>
+              <a:rPr sz="1300" b="0" i="0">
+                <a:solidFill>
+                  <a:srgbClr val="94A3B8"/>
+                </a:solidFill>
+                <a:latin typeface="Segoe UI"/>
+              </a:rPr>
+              <a:t>–  </a:t>
+            </a:r>
+            <a:r>
+              <a:rPr sz="1300" b="0" i="0">
+                <a:solidFill>
+                  <a:srgbClr val="5B6B80"/>
+                </a:solidFill>
+                <a:latin typeface="Segoe UI"/>
+              </a:rPr>
+              <a:t>SW view (8 Oct): 1/2" would not take the catalyst; 3/4" would be difficult.</a:t>
+            </a:r>
+          </a:p>
+          <a:p>
+            <a:pPr>
+              <a:spcBef>
+                <a:spcPts val="400"/>
+              </a:spcBef>
+            </a:pPr>
+            <a:r>
+              <a:rPr sz="1300" b="0" i="0">
+                <a:solidFill>
+                  <a:srgbClr val="94A3B8"/>
+                </a:solidFill>
+                <a:latin typeface="Segoe UI"/>
+              </a:rPr>
+              <a:t>–  </a:t>
+            </a:r>
+            <a:r>
+              <a:rPr sz="1300" b="0" i="0">
+                <a:solidFill>
+                  <a:srgbClr val="5B6B80"/>
+                </a:solidFill>
+                <a:latin typeface="Segoe UI"/>
+              </a:rPr>
+              <a:t>DN65 keeps the 1" charge and discharge nozzles already designed.</a:t>
+            </a:r>
+          </a:p>
+        </p:txBody>
+      </p:sp>
+      <p:sp>
+        <p:nvSpPr>
+          <p:cNvPr id="13" name="Rounded Rectangle 12"/>
+          <p:cNvSpPr/>
+          <p:nvPr/>
+        </p:nvSpPr>
+        <p:spPr>
+          <a:xfrm>
+            <a:off x="502920" y="3692652"/>
+            <a:ext cx="11183112" cy="1006982"/>
+          </a:xfrm>
+          <a:prstGeom prst="roundRect">
+            <a:avLst/>
+          </a:prstGeom>
+          <a:solidFill>
+            <a:srgbClr val="F4F7FB"/>
+          </a:solidFill>
+          <a:ln w="12700">
+            <a:solidFill>
+              <a:srgbClr val="E3E8F0"/>
+            </a:solidFill>
+          </a:ln>
+          <a:effectLst/>
+        </p:spPr>
+        <p:style>
+          <a:lnRef idx="1">
+            <a:schemeClr val="accent1"/>
+          </a:lnRef>
+          <a:fillRef idx="3">
+            <a:schemeClr val="accent1"/>
+          </a:fillRef>
+          <a:effectRef idx="2">
+            <a:schemeClr val="accent1"/>
+          </a:effectRef>
+          <a:fontRef idx="minor">
+            <a:schemeClr val="lt1"/>
+          </a:fontRef>
+        </p:style>
+        <p:txBody>
+          <a:bodyPr rtlCol="0" anchor="ctr"/>
+          <a:lstStyle/>
+          <a:p>
+            <a:pPr algn="ctr"/>
+          </a:p>
+        </p:txBody>
+      </p:sp>
+      <p:sp>
+        <p:nvSpPr>
+          <p:cNvPr id="14" name="Rectangle 13"/>
+          <p:cNvSpPr/>
+          <p:nvPr/>
+        </p:nvSpPr>
+        <p:spPr>
+          <a:xfrm>
+            <a:off x="502920" y="3692652"/>
+            <a:ext cx="64008" cy="1006982"/>
+          </a:xfrm>
+          <a:prstGeom prst="rect">
+            <a:avLst/>
+          </a:prstGeom>
+          <a:solidFill>
+            <a:srgbClr val="7C3AED"/>
+          </a:solidFill>
+          <a:ln>
+            <a:noFill/>
+          </a:ln>
+          <a:effectLst/>
+        </p:spPr>
+        <p:style>
+          <a:lnRef idx="1">
+            <a:schemeClr val="accent1"/>
+          </a:lnRef>
+          <a:fillRef idx="3">
+            <a:schemeClr val="accent1"/>
+          </a:fillRef>
+          <a:effectRef idx="2">
+            <a:schemeClr val="accent1"/>
+          </a:effectRef>
+          <a:fontRef idx="minor">
+            <a:schemeClr val="lt1"/>
+          </a:fontRef>
+        </p:style>
+        <p:txBody>
+          <a:bodyPr rtlCol="0" anchor="ctr"/>
+          <a:lstStyle/>
+          <a:p>
+            <a:pPr algn="ctr"/>
+          </a:p>
+        </p:txBody>
+      </p:sp>
+      <p:sp>
+        <p:nvSpPr>
+          <p:cNvPr id="15" name="TextBox 14"/>
+          <p:cNvSpPr txBox="1"/>
+          <p:nvPr/>
+        </p:nvSpPr>
+        <p:spPr>
+          <a:xfrm>
+            <a:off x="749808" y="3756660"/>
+            <a:ext cx="10744200" cy="915542"/>
+          </a:xfrm>
+          <a:prstGeom prst="rect">
+            <a:avLst/>
+          </a:prstGeom>
+          <a:noFill/>
+        </p:spPr>
+        <p:txBody>
+          <a:bodyPr wrap="square" lIns="0" rIns="0" tIns="0" bIns="0"/>
+          <a:lstStyle/>
+          <a:p>
+            <a:r>
+              <a:rPr sz="1600" b="1" i="0">
+                <a:solidFill>
+                  <a:srgbClr val="1E2B3A"/>
+                </a:solidFill>
+                <a:latin typeface="Segoe UI"/>
+              </a:rPr>
+              <a:t>Temperature: R&amp;D measured about 5–7 °C rise at DN40 and a 15–18 °C hot spot at DN65.  There is no DN50 data.</a:t>
+            </a:r>
+          </a:p>
+          <a:p>
+            <a:pPr>
+              <a:spcBef>
+                <a:spcPts val="400"/>
+              </a:spcBef>
+            </a:pPr>
+            <a:r>
+              <a:rPr sz="1300" b="0" i="0">
+                <a:solidFill>
+                  <a:srgbClr val="94A3B8"/>
+                </a:solidFill>
+                <a:latin typeface="Segoe UI"/>
+              </a:rPr>
+              <a:t>–  </a:t>
+            </a:r>
+            <a:r>
+              <a:rPr sz="1300" b="0" i="0">
+                <a:solidFill>
+                  <a:srgbClr val="5B6B80"/>
+                </a:solidFill>
+                <a:latin typeface="Segoe UI"/>
+              </a:rPr>
+              <a:t>At DN65 the hot spot can be controlled by diluting the catalyst bed with inert material at loading.</a:t>
+            </a:r>
+          </a:p>
+        </p:txBody>
+      </p:sp>
+      <p:sp>
+        <p:nvSpPr>
+          <p:cNvPr id="16" name="Rounded Rectangle 15"/>
+          <p:cNvSpPr/>
+          <p:nvPr/>
+        </p:nvSpPr>
+        <p:spPr>
+          <a:xfrm>
+            <a:off x="502920" y="4791074"/>
+            <a:ext cx="11183112" cy="745744"/>
+          </a:xfrm>
+          <a:prstGeom prst="roundRect">
+            <a:avLst/>
+          </a:prstGeom>
+          <a:solidFill>
+            <a:srgbClr val="F4F7FB"/>
+          </a:solidFill>
+          <a:ln w="12700">
+            <a:solidFill>
+              <a:srgbClr val="E3E8F0"/>
+            </a:solidFill>
+          </a:ln>
+          <a:effectLst/>
+        </p:spPr>
+        <p:style>
+          <a:lnRef idx="1">
+            <a:schemeClr val="accent1"/>
+          </a:lnRef>
+          <a:fillRef idx="3">
+            <a:schemeClr val="accent1"/>
+          </a:fillRef>
+          <a:effectRef idx="2">
+            <a:schemeClr val="accent1"/>
+          </a:effectRef>
+          <a:fontRef idx="minor">
+            <a:schemeClr val="lt1"/>
+          </a:fontRef>
+        </p:style>
+        <p:txBody>
+          <a:bodyPr rtlCol="0" anchor="ctr"/>
+          <a:lstStyle/>
+          <a:p>
+            <a:pPr algn="ctr"/>
+          </a:p>
+        </p:txBody>
+      </p:sp>
+      <p:sp>
+        <p:nvSpPr>
+          <p:cNvPr id="17" name="Rectangle 16"/>
+          <p:cNvSpPr/>
+          <p:nvPr/>
+        </p:nvSpPr>
+        <p:spPr>
+          <a:xfrm>
+            <a:off x="502920" y="4791074"/>
+            <a:ext cx="64008" cy="745744"/>
+          </a:xfrm>
+          <a:prstGeom prst="rect">
+            <a:avLst/>
+          </a:prstGeom>
+          <a:solidFill>
+            <a:srgbClr val="7C3AED"/>
+          </a:solidFill>
+          <a:ln>
+            <a:noFill/>
+          </a:ln>
+          <a:effectLst/>
+        </p:spPr>
+        <p:style>
+          <a:lnRef idx="1">
+            <a:schemeClr val="accent1"/>
+          </a:lnRef>
+          <a:fillRef idx="3">
+            <a:schemeClr val="accent1"/>
+          </a:fillRef>
+          <a:effectRef idx="2">
+            <a:schemeClr val="accent1"/>
+          </a:effectRef>
+          <a:fontRef idx="minor">
+            <a:schemeClr val="lt1"/>
+          </a:fontRef>
+        </p:style>
+        <p:txBody>
+          <a:bodyPr rtlCol="0" anchor="ctr"/>
+          <a:lstStyle/>
+          <a:p>
+            <a:pPr algn="ctr"/>
+          </a:p>
+        </p:txBody>
+      </p:sp>
+      <p:sp>
+        <p:nvSpPr>
+          <p:cNvPr id="18" name="TextBox 17"/>
+          <p:cNvSpPr txBox="1"/>
+          <p:nvPr/>
+        </p:nvSpPr>
+        <p:spPr>
+          <a:xfrm>
+            <a:off x="749808" y="4855082"/>
+            <a:ext cx="10744200" cy="654304"/>
+          </a:xfrm>
+          <a:prstGeom prst="rect">
+            <a:avLst/>
+          </a:prstGeom>
+          <a:noFill/>
+        </p:spPr>
+        <p:txBody>
+          <a:bodyPr wrap="square" lIns="0" rIns="0" tIns="0" bIns="0"/>
+          <a:lstStyle/>
+          <a:p>
+            <a:r>
+              <a:rPr sz="1600" b="1" i="0">
+                <a:solidFill>
+                  <a:srgbClr val="1E2B3A"/>
+                </a:solidFill>
+                <a:latin typeface="Segoe UI"/>
+              </a:rPr>
+              <a:t>Fits the skid height; DN50 would need a longer column for the same volume.  PFD and mass balance are unchanged; the DN65 relief calculation already exists.</a:t>
+            </a:r>
+          </a:p>
+        </p:txBody>
+      </p:sp>
+      <p:sp>
+        <p:nvSpPr>
+          <p:cNvPr id="19" name="TextBox 18"/>
+          <p:cNvSpPr txBox="1"/>
+          <p:nvPr/>
+        </p:nvSpPr>
+        <p:spPr>
+          <a:xfrm>
+            <a:off x="548640" y="6446520"/>
+            <a:ext cx="6583680" cy="274320"/>
+          </a:xfrm>
+          <a:prstGeom prst="rect">
+            <a:avLst/>
+          </a:prstGeom>
+          <a:noFill/>
+        </p:spPr>
+        <p:txBody>
+          <a:bodyPr wrap="none">
+            <a:spAutoFit/>
+          </a:bodyPr>
+          <a:lstStyle/>
+          <a:p>
+            <a:r>
+              <a:rPr sz="900" b="0" i="0">
+                <a:solidFill>
+                  <a:srgbClr val="9AA6B8"/>
+                </a:solidFill>
+                <a:latin typeface="Segoe UI"/>
+              </a:rPr>
+              <a:t>Asymchem · Sandwich Site   |   Continuous Hydrogenation Skid</a:t>
+            </a:r>
+          </a:p>
+        </p:txBody>
+      </p:sp>
+      <p:sp>
+        <p:nvSpPr>
+          <p:cNvPr id="20" name="TextBox 19"/>
+          <p:cNvSpPr txBox="1"/>
+          <p:nvPr/>
+        </p:nvSpPr>
+        <p:spPr>
+          <a:xfrm>
+            <a:off x="6949440" y="6446520"/>
+            <a:ext cx="4663440" cy="274320"/>
+          </a:xfrm>
+          <a:prstGeom prst="rect">
+            <a:avLst/>
+          </a:prstGeom>
+          <a:noFill/>
+        </p:spPr>
+        <p:txBody>
+          <a:bodyPr wrap="none">
+            <a:spAutoFit/>
+          </a:bodyPr>
+          <a:lstStyle/>
+          <a:p>
+            <a:pPr algn="r"/>
+            <a:r>
+              <a:rPr sz="900" b="0" i="0">
+                <a:solidFill>
+                  <a:srgbClr val="9AA6B8"/>
+                </a:solidFill>
+                <a:latin typeface="Segoe UI"/>
+              </a:rPr>
+              <a:t>Progress 2026-09-23 ~ 10-21    ·    07 / 08</a:t>
+            </a:r>
+          </a:p>
+        </p:txBody>
+      </p:sp>
+    </p:spTree>
+  </p:cSld>
+  <p:clrMapOvr>
+    <a:masterClrMapping/>
+  </p:clrMapOvr>
+</p:sld>
+</file>
+
+<file path=ppt/slides/slide8.xml><?xml version="1.0" encoding="utf-8"?>
+<p:sld xmlns:a="http://schemas.openxmlformats.org/drawingml/2006/main" xmlns:p="http://schemas.openxmlformats.org/presentationml/2006/main" xmlns:r="http://schemas.openxmlformats.org/officeDocument/2006/relationships">
+  <p:cSld>
+    <p:spTree>
+      <p:nvGrpSpPr>
+        <p:cNvPr id="1" name=""/>
+        <p:cNvGrpSpPr/>
+        <p:nvPr/>
+      </p:nvGrpSpPr>
+      <p:grpSpPr/>
+      <p:sp>
+        <p:nvSpPr>
+          <p:cNvPr id="2" name="Rectangle 1"/>
+          <p:cNvSpPr/>
+          <p:nvPr/>
+        </p:nvSpPr>
+        <p:spPr>
+          <a:xfrm>
+            <a:off x="0" y="0"/>
+            <a:ext cx="12191695" cy="146304"/>
+          </a:xfrm>
+          <a:prstGeom prst="rect">
             <a:avLst/>
           </a:prstGeom>
           <a:solidFill>
@@ -9606,6 +10455,50 @@
       </p:sp>
       <p:sp>
         <p:nvSpPr>
+          <p:cNvPr id="3" name="Rounded Rectangle 2"/>
+          <p:cNvSpPr/>
+          <p:nvPr/>
+        </p:nvSpPr>
+        <p:spPr>
+          <a:xfrm>
+            <a:off x="502920" y="347472"/>
+            <a:ext cx="841248" cy="841248"/>
+          </a:xfrm>
+          <a:prstGeom prst="roundRect">
+            <a:avLst/>
+          </a:prstGeom>
+          <a:solidFill>
+            <a:srgbClr val="0E9AA7"/>
+          </a:solidFill>
+          <a:ln>
+            <a:noFill/>
+          </a:ln>
+          <a:effectLst/>
+        </p:spPr>
+        <p:style>
+          <a:lnRef idx="1">
+            <a:schemeClr val="accent1"/>
+          </a:lnRef>
+          <a:fillRef idx="3">
+            <a:schemeClr val="accent1"/>
+          </a:fillRef>
+          <a:effectRef idx="2">
+            <a:schemeClr val="accent1"/>
+          </a:effectRef>
+          <a:fontRef idx="minor">
+            <a:schemeClr val="lt1"/>
+          </a:fontRef>
+        </p:style>
+        <p:txBody>
+          <a:bodyPr rtlCol="0" anchor="ctr"/>
+          <a:lstStyle/>
+          <a:p>
+            <a:pPr algn="ctr"/>
+          </a:p>
+        </p:txBody>
+      </p:sp>
+      <p:sp>
+        <p:nvSpPr>
           <p:cNvPr id="4" name="TextBox 3"/>
           <p:cNvSpPr txBox="1"/>
           <p:nvPr/>
@@ -9634,7 +10527,7 @@
                 </a:solidFill>
                 <a:latin typeface="Segoe UI"/>
               </a:rPr>
-              <a:t>07</a:t>
+              <a:t>08</a:t>
             </a:r>
           </a:p>
         </p:txBody>
@@ -9850,7 +10743,7 @@
                 </a:solidFill>
                 <a:latin typeface="Segoe UI"/>
               </a:rPr>
-              <a:t>SW (Keith) — review the 20 Oct model: SE01 / CU01 position, drain and CIP valves, cabinet positions, three-head pump.</a:t>
+              <a:t>CFCT (Fan Shuangshuang) — P&amp;ID walk-through on the model; SE01 / CU01 on the end face; jacket-nozzle sketch to SW.</a:t>
             </a:r>
           </a:p>
         </p:txBody>
@@ -9864,7 +10757,7 @@
         <p:spPr>
           <a:xfrm>
             <a:off x="502920" y="2023618"/>
-            <a:ext cx="11183112" cy="682244"/>
+            <a:ext cx="11183112" cy="459994"/>
           </a:xfrm>
           <a:prstGeom prst="roundRect">
             <a:avLst/>
@@ -9910,7 +10803,7 @@
         <p:spPr>
           <a:xfrm>
             <a:off x="502920" y="2023618"/>
-            <a:ext cx="64008" cy="682244"/>
+            <a:ext cx="64008" cy="459994"/>
           </a:xfrm>
           <a:prstGeom prst="rect">
             <a:avLst/>
@@ -9954,7 +10847,7 @@
         <p:spPr>
           <a:xfrm>
             <a:off x="749808" y="2087625"/>
-            <a:ext cx="10744200" cy="590804"/>
+            <a:ext cx="10744200" cy="368554"/>
           </a:xfrm>
           <a:prstGeom prst="rect">
             <a:avLst/>
@@ -9972,7 +10865,7 @@
                 </a:solidFill>
                 <a:latin typeface="Segoe UI"/>
               </a:rPr>
-              <a:t>CFCT (Fan Shuangshuang) — freeze nozzle orientation and HTF routes, then release the main-equipment drawings for enquiry.</a:t>
+              <a:t>Then freeze nozzle orientation and HTF routes, and release the main-equipment drawings for enquiry.</a:t>
             </a:r>
           </a:p>
         </p:txBody>
@@ -9985,8 +10878,8 @@
         </p:nvSpPr>
         <p:spPr>
           <a:xfrm>
-            <a:off x="502920" y="2788157"/>
-            <a:ext cx="11183112" cy="459994"/>
+            <a:off x="502920" y="2565908"/>
+            <a:ext cx="11183112" cy="682244"/>
           </a:xfrm>
           <a:prstGeom prst="roundRect">
             <a:avLst/>
@@ -10031,8 +10924,8 @@
         </p:nvSpPr>
         <p:spPr>
           <a:xfrm>
-            <a:off x="502920" y="2788157"/>
-            <a:ext cx="64008" cy="459994"/>
+            <a:off x="502920" y="2565908"/>
+            <a:ext cx="64008" cy="682244"/>
           </a:xfrm>
           <a:prstGeom prst="rect">
             <a:avLst/>
@@ -10075,8 +10968,8 @@
         </p:nvSpPr>
         <p:spPr>
           <a:xfrm>
-            <a:off x="749808" y="2852165"/>
-            <a:ext cx="10744200" cy="368554"/>
+            <a:off x="749808" y="2629915"/>
+            <a:ext cx="10744200" cy="590804"/>
           </a:xfrm>
           <a:prstGeom prst="rect">
             <a:avLst/>
@@ -10094,7 +10987,7 @@
                 </a:solidFill>
                 <a:latin typeface="Segoe UI"/>
               </a:rPr>
-              <a:t>CIMT (Meng Dezhi) — align the Siemens IS I/O module list and Profinet / Profibus; agree UK or China purchase.</a:t>
+              <a:t>Process (Hu Chaoqun) — remove CV06 and move its interlock to CV12; send SW the pump vendor discussion and pulsation curves.</a:t>
             </a:r>
           </a:p>
         </p:txBody>
@@ -10108,7 +11001,7 @@
         <p:spPr>
           <a:xfrm>
             <a:off x="502920" y="3330447"/>
-            <a:ext cx="11183112" cy="459994"/>
+            <a:ext cx="11183112" cy="682244"/>
           </a:xfrm>
           <a:prstGeom prst="roundRect">
             <a:avLst/>
@@ -10154,7 +11047,7 @@
         <p:spPr>
           <a:xfrm>
             <a:off x="502920" y="3330447"/>
-            <a:ext cx="64008" cy="459994"/>
+            <a:ext cx="64008" cy="682244"/>
           </a:xfrm>
           <a:prstGeom prst="rect">
             <a:avLst/>
@@ -10198,7 +11091,7 @@
         <p:spPr>
           <a:xfrm>
             <a:off x="749808" y="3394455"/>
-            <a:ext cx="10744200" cy="368554"/>
+            <a:ext cx="10744200" cy="590804"/>
           </a:xfrm>
           <a:prstGeom prst="rect">
             <a:avLst/>
@@ -10216,7 +11109,7 @@
                 </a:solidFill>
                 <a:latin typeface="Segoe UI"/>
               </a:rPr>
-              <a:t>Instruments (Gao Yu) — E+H parameter review; apply the multipoint RTD concept to other temperature points where it suits.</a:t>
+              <a:t>Instruments / CIMT — single-point temperature approach; Siemens IS I/O module list and Profinet / Profibus; UK or China purchase.</a:t>
             </a:r>
           </a:p>
         </p:txBody>
@@ -10229,7 +11122,7 @@
         </p:nvSpPr>
         <p:spPr>
           <a:xfrm>
-            <a:off x="502920" y="3872737"/>
+            <a:off x="502920" y="4094987"/>
             <a:ext cx="11183112" cy="459994"/>
           </a:xfrm>
           <a:prstGeom prst="roundRect">
@@ -10275,7 +11168,7 @@
         </p:nvSpPr>
         <p:spPr>
           <a:xfrm>
-            <a:off x="502920" y="3872737"/>
+            <a:off x="502920" y="4094987"/>
             <a:ext cx="64008" cy="459994"/>
           </a:xfrm>
           <a:prstGeom prst="rect">
@@ -10319,7 +11212,7 @@
         </p:nvSpPr>
         <p:spPr>
           <a:xfrm>
-            <a:off x="749808" y="3936746"/>
+            <a:off x="749808" y="4158995"/>
             <a:ext cx="10744200" cy="368554"/>
           </a:xfrm>
           <a:prstGeom prst="rect">
@@ -10338,7 +11231,7 @@
                 </a:solidFill>
                 <a:latin typeface="Segoe UI"/>
               </a:rPr>
-              <a:t>Process (Hu Chaoqun) — confirm feed-flow measurement against the three-head pulsation curves.</a:t>
+              <a:t>R&amp;D (Dr Feng) — catalyst loading and bed-dilution procedure for R24-CR01 at DN65.</a:t>
             </a:r>
           </a:p>
         </p:txBody>
@@ -10351,7 +11244,7 @@
         </p:nvSpPr>
         <p:spPr>
           <a:xfrm>
-            <a:off x="502920" y="4415028"/>
+            <a:off x="502920" y="4637278"/>
             <a:ext cx="11183112" cy="459994"/>
           </a:xfrm>
           <a:prstGeom prst="roundRect">
@@ -10397,7 +11290,7 @@
         </p:nvSpPr>
         <p:spPr>
           <a:xfrm>
-            <a:off x="502920" y="4415028"/>
+            <a:off x="502920" y="4637278"/>
             <a:ext cx="64008" cy="459994"/>
           </a:xfrm>
           <a:prstGeom prst="rect">
@@ -10441,7 +11334,7 @@
         </p:nvSpPr>
         <p:spPr>
           <a:xfrm>
-            <a:off x="749808" y="4479036"/>
+            <a:off x="749808" y="4701286"/>
             <a:ext cx="10744200" cy="368554"/>
           </a:xfrm>
           <a:prstGeom prst="rect">
@@ -10460,7 +11353,7 @@
                 </a:solidFill>
                 <a:latin typeface="Segoe UI"/>
               </a:rPr>
-              <a:t>R&amp;D (Dr Feng) — catalyst loading and bed-dilution procedure for R24-CR01 at DN65.</a:t>
+              <a:t>CFCT — re-estimate assembly, certification and freight; update the budget comparison.</a:t>
             </a:r>
           </a:p>
         </p:txBody>
@@ -10473,7 +11366,7 @@
         </p:nvSpPr>
         <p:spPr>
           <a:xfrm>
-            <a:off x="502920" y="4957317"/>
+            <a:off x="502920" y="5179567"/>
             <a:ext cx="11183112" cy="459994"/>
           </a:xfrm>
           <a:prstGeom prst="roundRect">
@@ -10519,7 +11412,7 @@
         </p:nvSpPr>
         <p:spPr>
           <a:xfrm>
-            <a:off x="502920" y="4957317"/>
+            <a:off x="502920" y="5179567"/>
             <a:ext cx="64008" cy="459994"/>
           </a:xfrm>
           <a:prstGeom prst="rect">
@@ -10563,7 +11456,7 @@
         </p:nvSpPr>
         <p:spPr>
           <a:xfrm>
-            <a:off x="749808" y="5021326"/>
+            <a:off x="749808" y="5243575"/>
             <a:ext cx="10744200" cy="368554"/>
           </a:xfrm>
           <a:prstGeom prst="rect">
@@ -10582,7 +11475,7 @@
                 </a:solidFill>
                 <a:latin typeface="Segoe UI"/>
               </a:rPr>
-              <a:t>CFCT — re-estimate assembly, certification and freight; update the budget comparison.</a:t>
+              <a:t>Site visit planned for the week of 2 November, subject to visas; confirmation early next week.</a:t>
             </a:r>
           </a:p>
         </p:txBody>
@@ -10651,7 +11544,7 @@
                 </a:solidFill>
                 <a:latin typeface="Segoe UI"/>
               </a:rPr>
-              <a:t>Progress 2026-09-23 ~ 10-21    ·    07 / 07</a:t>
+              <a:t>Progress 2026-09-23 ~ 10-21    ·    08 / 08</a:t>
             </a:r>
           </a:p>
         </p:txBody>

</xml_diff>